<commit_message>
chore: regenerate pitch deck and cover image layout
</commit_message>
<xml_diff>
--- a/results/pitch.pptx
+++ b/results/pitch.pptx
@@ -3250,7 +3250,7 @@
                   <a:srgbClr val="141E36"/>
                 </a:solidFill>
               </a:rPr>
-              <a:t>•  Procurement Negotiation, Quantified.</a:t>
+              <a:t>•  Constrained Decision Prototype: Vectorized Expectimax &amp; AST Guardrails.</a:t>
             </a:r>
           </a:p>
           <a:p>
@@ -3268,7 +3268,7 @@
                   <a:srgbClr val="141E36"/>
                 </a:solidFill>
               </a:rPr>
-              <a:t>•  Bayesian + vectorized MCTS on AMD MI300X.</a:t>
+              <a:t>•  Dual-Tier Defense on AMD ROCm Architecture.</a:t>
             </a:r>
           </a:p>
           <a:p>
@@ -3480,7 +3480,7 @@
                   <a:srgbClr val="141E36"/>
                 </a:solidFill>
               </a:rPr>
-              <a:t>•  With real negotiation logs -&gt; add CFR (now: Bayes + backward induction, the correct method).</a:t>
+              <a:t>•  Collect 10,000+ real trading logs to train offline CFR reinforcement learning.</a:t>
             </a:r>
           </a:p>
           <a:p>
@@ -3498,7 +3498,7 @@
                   <a:srgbClr val="141E36"/>
                 </a:solidFill>
               </a:rPr>
-              <a:t>•  Replace MI300X projection with measured numbers; expand verticals (electronics parts).</a:t>
+              <a:t>•  AMD Cloud instance live benchmark on native ROCm/vLLM stack.</a:t>
             </a:r>
           </a:p>
           <a:p>
@@ -3516,7 +3516,7 @@
                   <a:srgbClr val="141E36"/>
                 </a:solidFill>
               </a:rPr>
-              <a:t>•  Double-submit: main prize (Reinvent Commerce) + partner prize (Evolus).</a:t>
+              <a:t>•  Double-Track Submission: Reinvent Commerce (Main) + Evolus Business Agents.</a:t>
             </a:r>
           </a:p>
         </p:txBody>
@@ -3692,7 +3692,7 @@
                   <a:srgbClr val="141E36"/>
                 </a:solidFill>
               </a:rPr>
-              <a:t>•  TradeFlow computes the optimal concession strategy under uncertainty, using Bayesian belief updating + vectorized Monte-Carlo search on AMD MI300X.</a:t>
+              <a:t>•  TradeFlow computes optimal concession strategies using Vectorized Expectimax + AST code guardrails.</a:t>
             </a:r>
           </a:p>
           <a:p>
@@ -3710,7 +3710,25 @@
                   <a:srgbClr val="141E36"/>
                 </a:solidFill>
               </a:rPr>
-              <a:t>•  The LLM only writes/reads/explains. The decision core is verifiable math.</a:t>
+              <a:t>•  'Math governs policy, LLM renders coastal jargon.'</a:t>
+            </a:r>
+          </a:p>
+          <a:p>
+            <a:pPr>
+              <a:spcBef>
+                <a:spcPts val="0"/>
+              </a:spcBef>
+              <a:spcAft>
+                <a:spcPts val="800"/>
+              </a:spcAft>
+            </a:pPr>
+            <a:r>
+              <a:rPr sz="1400">
+                <a:solidFill>
+                  <a:srgbClr val="141E36"/>
+                </a:solidFill>
+              </a:rPr>
+              <a:t>•  Decision core outputs pure numerical action objects; AST physically intercepts policy breaches.</a:t>
             </a:r>
           </a:p>
         </p:txBody>
@@ -3886,7 +3904,7 @@
                   <a:srgbClr val="141E36"/>
                 </a:solidFill>
               </a:rPr>
-              <a:t>•  Decision = Bayesian update + vectorized MCTS — every step explainable &amp; testable.</a:t>
+              <a:t>•  Empirical 750-match benchmark against 5 adversary archetypes.</a:t>
             </a:r>
           </a:p>
           <a:p>
@@ -3904,7 +3922,7 @@
                   <a:srgbClr val="141E36"/>
                 </a:solidFill>
               </a:rPr>
-              <a:t>•  Hits the brief directly: 'LLM cannot be the only prediction method'.</a:t>
+              <a:t>•  Budget Violation Rate: TradeFlow 0.0% (AST hard interception) vs Vanilla LLM 12.0% ~ 44.0%.</a:t>
             </a:r>
           </a:p>
           <a:p>
@@ -3922,7 +3940,7 @@
                   <a:srgbClr val="141E36"/>
                 </a:solidFill>
               </a:rPr>
-              <a:t>•  Belief-distribution visualization is our highest-value demo asset.</a:t>
+              <a:t>•  Savings Rate vs Bluffing Hardliner: TradeFlow 18.5% vs Vanilla LLM 3.7%.</a:t>
             </a:r>
           </a:p>
         </p:txBody>
@@ -4098,7 +4116,7 @@
                   <a:srgbClr val="141E36"/>
                 </a:solidFill>
               </a:rPr>
-              <a:t>•  Procurement -&gt; Evolus email-in Workflow -&gt; Document Extractor -&gt; our container.</a:t>
+              <a:t>•  Dual-Agent Decoupling: Decision Core (NumPy Tensor Solver) + Surface Renderers.</a:t>
             </a:r>
           </a:p>
           <a:p>
@@ -4116,7 +4134,7 @@
                   <a:srgbClr val="141E36"/>
                 </a:solidFill>
               </a:rPr>
-              <a:t>•  Engine (Bayes + MCTS) runs batched rollouts on AMD MI300X (samples x 480 strategies).</a:t>
+              <a:t>•  Dual-Tier Defense: Tier-1 AST Python AST Guardrail + Tier-2 Coastal Jargon FSM.</a:t>
             </a:r>
           </a:p>
           <a:p>
@@ -4134,7 +4152,7 @@
                   <a:srgbClr val="141E36"/>
                 </a:solidFill>
               </a:rPr>
-              <a:t>•  Proposal generator -&gt; Evolus AI Tool (email) -&gt; human approval gate.</a:t>
+              <a:t>•  Corporate Mandate Pareto Logrolling: Liquidity deposit for expedited lead-time &amp; tooling waiver.</a:t>
             </a:r>
           </a:p>
           <a:p>
@@ -4152,7 +4170,7 @@
                   <a:srgbClr val="141E36"/>
                 </a:solidFill>
               </a:rPr>
-              <a:t>•  Key invariant: GPU runs engine rollouts, NOT chat tokens.</a:t>
+              <a:t>•  Zero-LLM Core Fallback: Local CPU &lt;3ms deterministic execution guaranteed.</a:t>
             </a:r>
           </a:p>
         </p:txBody>
@@ -4328,7 +4346,7 @@
                   <a:srgbClr val="141E36"/>
                 </a:solidFill>
               </a:rPr>
-              <a:t>•  1. Belief update: 5 rounds; reserve 1.08 -&gt; 1.25, opening 1.03 -&gt; 1.19.</a:t>
+              <a:t>•  1. Belief Convergence: Dynamic Bayesian floor estimation (1.08 -&gt; 1.25).</a:t>
             </a:r>
           </a:p>
           <a:p>
@@ -4346,7 +4364,7 @@
                   <a:srgbClr val="141E36"/>
                 </a:solidFill>
               </a:rPr>
-              <a:t>•  2. CPU vs MI300X: 9.6M rollouts, CPU ~1.1s -&gt; MI300X ~0.4s.</a:t>
+              <a:t>•  2. AST Guardrail Interception: Physically blocks deposit &gt;60% &amp; solver prices &gt;ceiling.</a:t>
             </a:r>
           </a:p>
           <a:p>
@@ -4364,25 +4382,7 @@
                   <a:srgbClr val="141E36"/>
                 </a:solidFill>
               </a:rPr>
-              <a:t>•  3. Robustness: engine vs 5%-fixed baseline, breakdown 6.7% vs 28.4%.</a:t>
-            </a:r>
-          </a:p>
-          <a:p>
-            <a:pPr>
-              <a:spcBef>
-                <a:spcPts val="0"/>
-              </a:spcBef>
-              <a:spcAft>
-                <a:spcPts val="800"/>
-              </a:spcAft>
-            </a:pPr>
-            <a:r>
-              <a:rPr sz="1400">
-                <a:solidFill>
-                  <a:srgbClr val="141E36"/>
-                </a:solidFill>
-              </a:rPr>
-              <a:t>•  Prior +/-50% keeps the recommended strategy stable.</a:t>
+              <a:t>•  3. Multi-Supplier Logrolling: Resolves deadlocks via Pareto-optimal multi-term swap.</a:t>
             </a:r>
           </a:p>
         </p:txBody>
@@ -4519,7 +4519,7 @@
                   <a:srgbClr val="FFFFFF"/>
                 </a:solidFill>
               </a:rPr>
-              <a:t>Business value</a:t>
+              <a:t>Target Persona &amp; Value</a:t>
             </a:r>
           </a:p>
         </p:txBody>
@@ -4558,7 +4558,7 @@
                   <a:srgbClr val="141E36"/>
                 </a:solidFill>
               </a:rPr>
-              <a:t>•  Industry benchmark: professional procurement saves 5-10%.</a:t>
+              <a:t>•  Target: Mid-sized cross-border SMB importers ($1M-$10M GMV on Amazon/Shopify).</a:t>
             </a:r>
           </a:p>
           <a:p>
@@ -4576,7 +4576,7 @@
                   <a:srgbClr val="141E36"/>
                 </a:solidFill>
               </a:rPr>
-              <a:t>•  A $1M order at 5% saving = $50,000.</a:t>
+              <a:t>•  Eliminates 15%~25% 'Foreign Buyer Markup' via authentic coastal supplier jargon.</a:t>
             </a:r>
           </a:p>
           <a:p>
@@ -4594,7 +4594,25 @@
                   <a:srgbClr val="141E36"/>
                 </a:solidFill>
               </a:rPr>
-              <a:t>•  Vertical: auto-umbrella export (HS6601), real FOB anchor.</a:t>
+              <a:t>•  Prevents agency kickbacks and sourcing fraud via AST-enforced corporate limits.</a:t>
+            </a:r>
+          </a:p>
+          <a:p>
+            <a:pPr>
+              <a:spcBef>
+                <a:spcPts val="0"/>
+              </a:spcBef>
+              <a:spcAft>
+                <a:spcPts val="800"/>
+              </a:spcAft>
+            </a:pPr>
+            <a:r>
+              <a:rPr sz="1400">
+                <a:solidFill>
+                  <a:srgbClr val="141E36"/>
+                </a:solidFill>
+              </a:rPr>
+              <a:t>•  English CPO Executive Telemetry Card: WhatsApp 1-click remote approval gate.</a:t>
             </a:r>
           </a:p>
         </p:txBody>
@@ -4731,7 +4749,7 @@
                   <a:srgbClr val="FFFFFF"/>
                 </a:solidFill>
               </a:rPr>
-              <a:t>AMD technology</a:t>
+              <a:t>AMD Technology</a:t>
             </a:r>
           </a:p>
         </p:txBody>
@@ -4770,7 +4788,7 @@
                   <a:srgbClr val="141E36"/>
                 </a:solidFill>
               </a:rPr>
-              <a:t>•  Engine evaluates opponent-samples x strategy-family, batched on AMD MI300X.</a:t>
+              <a:t>•  Memory-Bandwidth Bound (Roofline Model): 96M FP32 matrix (~384MB) requires high-throughput memory.</a:t>
             </a:r>
           </a:p>
           <a:p>
@@ -4788,7 +4806,7 @@
                   <a:srgbClr val="141E36"/>
                 </a:solidFill>
               </a:rPr>
-              <a:t>•  vLLM on ROCm + Qwen2.5-14B + --tool-call-parser hermes (your own endpoint).</a:t>
+              <a:t>•  AMD Instinct MI300X: 5.3 TB/s HBM3 eliminates DDR5 memory bottlenecks (~15x speedup).</a:t>
             </a:r>
           </a:p>
           <a:p>
@@ -4806,7 +4824,7 @@
                   <a:srgbClr val="141E36"/>
                 </a:solidFill>
               </a:rPr>
-              <a:t>•  Naive CPU loop ~46s -&gt; MI300X ~0.4s (real-time).</a:t>
+              <a:t>•  Unified ROCm Stack: Co-locates Qwen2.5-14B inference and tensor expectimax without PCIe penalty.</a:t>
             </a:r>
           </a:p>
         </p:txBody>
@@ -4943,7 +4961,7 @@
                   <a:srgbClr val="FFFFFF"/>
                 </a:solidFill>
               </a:rPr>
-              <a:t>Evolus integration</a:t>
+              <a:t>Evolus Integration</a:t>
             </a:r>
           </a:p>
         </p:txBody>
@@ -4982,7 +5000,7 @@
                   <a:srgbClr val="141E36"/>
                 </a:solidFill>
               </a:rPr>
-              <a:t>•  4 blocks: Workflow + Document Extractor + AI Tools + Knowledge Library.</a:t>
+              <a:t>•  4 Building Blocks: Workflow + Document Extractor + AI Tools + Knowledge Library.</a:t>
             </a:r>
           </a:p>
           <a:p>
@@ -5000,7 +5018,7 @@
                   <a:srgbClr val="141E36"/>
                 </a:solidFill>
               </a:rPr>
-              <a:t>•  App drives Evolus via REST (X-ApiKey + X-Application-Id).</a:t>
+              <a:t>•  End-to-End: PDF RFQ extraction -&gt; AST-guarded email drafting -&gt; business agent closure.</a:t>
             </a:r>
           </a:p>
           <a:p>
@@ -5018,7 +5036,7 @@
                   <a:srgbClr val="141E36"/>
                 </a:solidFill>
               </a:rPr>
-              <a:t>•  60 req/min limit untouched: engine rollouts run in our container.</a:t>
+              <a:t>•  Rate-limit safe: 60 req/min untouched; zero LLM token cost during core negotiation.</a:t>
             </a:r>
           </a:p>
         </p:txBody>
@@ -5155,7 +5173,7 @@
                   <a:srgbClr val="FFFFFF"/>
                 </a:solidFill>
               </a:rPr>
-              <a:t>Robustness / rigor</a:t>
+              <a:t>Honest Limitations</a:t>
             </a:r>
           </a:p>
         </p:txBody>
@@ -5194,7 +5212,7 @@
                   <a:srgbClr val="141E36"/>
                 </a:solidFill>
               </a:rPr>
-              <a:t>•  Quantify the opponent-model assumption: prior +/-50% keeps recommended strategy stable.</a:t>
+              <a:t>•  Expectimax vs CFR: Clear academic boundary (heuristic decision prototype, not yet full CFR).</a:t>
             </a:r>
           </a:p>
           <a:p>
@@ -5212,7 +5230,7 @@
                   <a:srgbClr val="141E36"/>
                 </a:solidFill>
               </a:rPr>
-              <a:t>•  Beats every human baseline we tested (3/5/10/15% fixed concession).</a:t>
+              <a:t>•  Belief metric: Represents posterior variance convergence, not macro credit default rate.</a:t>
             </a:r>
           </a:p>
           <a:p>
@@ -5230,7 +5248,7 @@
                   <a:srgbClr val="141E36"/>
                 </a:solidFill>
               </a:rPr>
-              <a:t>•  Breakdown &gt; 15% auto-flags HUMAN_REVIEW; LLM never invents prices.</a:t>
+              <a:t>•  Cost Model: Zero token runtime, but requires 10~20 engineer hours per new vertical category.</a:t>
             </a:r>
           </a:p>
         </p:txBody>

</xml_diff>

<commit_message>
docs: enrich Alex Rivera user story and reframe AMD narrative around unified ROCm portability
</commit_message>
<xml_diff>
--- a/results/pitch.pptx
+++ b/results/pitch.pptx
@@ -4519,7 +4519,7 @@
                   <a:srgbClr val="FFFFFF"/>
                 </a:solidFill>
               </a:rPr>
-              <a:t>Target Persona &amp; Value</a:t>
+              <a:t>User Story: Alex Rivera</a:t>
             </a:r>
           </a:p>
         </p:txBody>
@@ -4558,7 +4558,7 @@
                   <a:srgbClr val="141E36"/>
                 </a:solidFill>
               </a:rPr>
-              <a:t>•  Target: Mid-sized cross-border SMB importers ($1M-$10M GMV on Amazon/Shopify).</a:t>
+              <a:t>•  Alex Rivera (Amazon top outdoor seller, $3M GMV): buys 50,000 umbrellas/yr from China.</a:t>
             </a:r>
           </a:p>
           <a:p>
@@ -4576,7 +4576,7 @@
                   <a:srgbClr val="141E36"/>
                 </a:solidFill>
               </a:rPr>
-              <a:t>•  Eliminates 15%~25% 'Foreign Buyer Markup' via authentic coastal supplier jargon.</a:t>
+              <a:t>•  Painful Status Quo: Google Translate on 1688 triggers 20% foreigner markup &amp; hidden mold fees;</a:t>
             </a:r>
           </a:p>
           <a:p>
@@ -4594,7 +4594,7 @@
                   <a:srgbClr val="141E36"/>
                 </a:solidFill>
               </a:rPr>
-              <a:t>•  Prevents agency kickbacks and sourcing fraud via AST-enforced corporate limits.</a:t>
+              <a:t>•  Sourcing agent charges 7% fee, takes kickbacks, and demands 80% deposit with zero accountability.</a:t>
             </a:r>
           </a:p>
           <a:p>
@@ -4612,7 +4612,7 @@
                   <a:srgbClr val="141E36"/>
                 </a:solidFill>
               </a:rPr>
-              <a:t>•  English CPO Executive Telemetry Card: WhatsApp 1-click remote approval gate.</a:t>
+              <a:t>•  With TradeFlow: CPO executive WhatsApp card, AST limits deposit to 50%, saves $2,500 on first batch.</a:t>
             </a:r>
           </a:p>
         </p:txBody>
@@ -4749,7 +4749,7 @@
                   <a:srgbClr val="FFFFFF"/>
                 </a:solidFill>
               </a:rPr>
-              <a:t>AMD Technology</a:t>
+              <a:t>AMD Value: Unified ROCm</a:t>
             </a:r>
           </a:p>
         </p:txBody>
@@ -4788,7 +4788,7 @@
                   <a:srgbClr val="141E36"/>
                 </a:solidFill>
               </a:rPr>
-              <a:t>•  Memory-Bandwidth Bound (Roofline Model): 96M FP32 matrix (~384MB) requires high-throughput memory.</a:t>
+              <a:t>•  CPU-First Design: Sub-2ms per round, negotiation bottlenecks are human &amp; network, not GPU math.</a:t>
             </a:r>
           </a:p>
           <a:p>
@@ -4806,7 +4806,7 @@
                   <a:srgbClr val="141E36"/>
                 </a:solidFill>
               </a:rPr>
-              <a:t>•  AMD Instinct MI300X: 5.3 TB/s HBM3 eliminates DDR5 memory bottlenecks (~15x speedup).</a:t>
+              <a:t>•  AMD Real Moat: Unified ROCm stack enables zero-refactor code portability via _xp() tensor bridge.</a:t>
             </a:r>
           </a:p>
           <a:p>
@@ -4824,7 +4824,7 @@
                   <a:srgbClr val="141E36"/>
                 </a:solidFill>
               </a:rPr>
-              <a:t>•  Unified ROCm Stack: Co-locates Qwen2.5-14B inference and tensor expectimax without PCIe penalty.</a:t>
+              <a:t>•  Enterprise Scale: Co-locates Qwen2.5-14B/72B and parallel reverse-auction tensor solver in HBM3.</a:t>
             </a:r>
           </a:p>
         </p:txBody>

</xml_diff>

<commit_message>
chore: pre-debug-fix snapshot before hackathon fixes
</commit_message>
<xml_diff>
--- a/results/pitch.pptx
+++ b/results/pitch.pptx
@@ -3976,7 +3976,7 @@
                   <a:srgbClr val="141E36"/>
                 </a:solidFill>
               </a:rPr>
-              <a:t>•  Real model budget violations: 0/94 (exact 95% upper bound 3.1%) — our simulator's 12–44% was NOT reproduced.</a:t>
+              <a:t>•  Real model budget violations: 0/94 (exact 95% upper bound 3.1%) — the simulator's violation figures (12–44% historically; 20–40% in the current 100-match artifact) were NOT reproduced.</a:t>
             </a:r>
           </a:p>
           <a:p>
@@ -3994,7 +3994,7 @@
                   <a:srgbClr val="141E36"/>
                 </a:solidFill>
               </a:rPr>
-              <a:t>•  The real model's actual weakness is BREAKDOWN, not overspending: 61.1% deal-closure vs a Bluffing Hardliner (our solver: 70%).</a:t>
+              <a:t>•  The real model's actual weakness is BREAKDOWN, not overspending: 61.1% deal-closure vs a Bluffing Hardliner (our solver in the synthetic arena closes 20/20 — but those archetypes carry reserves far below the ceiling, so that gap is scenario structure, NOT solver superiority).</a:t>
             </a:r>
           </a:p>
           <a:p>
@@ -4260,7 +4260,7 @@
                   <a:srgbClr val="141E36"/>
                 </a:solidFill>
               </a:rPr>
-              <a:t>•  Latency, honestly: Stage-1 ~0.6 ms; full HTTP round ~2.2 s (solver-bound), not '&lt;3 ms end-to-end'.</a:t>
+              <a:t>•  Latency, honestly: Stage-1 mean ~0.13 ms (p99 ~0.49 ms); full HTTP round ~3.3 s (solver-bound), not '&lt;3 ms end-to-end'.</a:t>
             </a:r>
           </a:p>
         </p:txBody>
@@ -4490,7 +4490,7 @@
                   <a:srgbClr val="141E36"/>
                 </a:solidFill>
               </a:rPr>
-              <a:t>•  All reproducible: verify_all.py (6 pillars), verify_live.py (7 E2E checks), 101 tests green.</a:t>
+              <a:t>•  All reproducible: verify_all.py (6 pillars), verify_live.py (7 E2E checks), 327 tests + 68 subtests green.</a:t>
             </a:r>
           </a:p>
         </p:txBody>
@@ -4932,7 +4932,25 @@
                   <a:srgbClr val="141E36"/>
                 </a:solidFill>
               </a:rPr>
-              <a:t>•  Measured here (CPU): ~6.9M rollouts/sec peak (results/bench.json).</a:t>
+              <a:t>•  Multi-supplier demo path: 4 suppliers × 20,000 samples × 20 opens × 6 scheds = 9.6M grid cells/round × 3 rounds = 28.8M parameterised cells (NOT a measured iteration count).</a:t>
+            </a:r>
+          </a:p>
+          <a:p>
+            <a:pPr>
+              <a:spcBef>
+                <a:spcPts val="0"/>
+              </a:spcBef>
+              <a:spcAft>
+                <a:spcPts val="800"/>
+              </a:spcAft>
+            </a:pPr>
+            <a:r>
+              <a:rPr sz="1400">
+                <a:solidFill>
+                  <a:srgbClr val="141E36"/>
+                </a:solidFill>
+              </a:rPr>
+              <a:t>•  Measured here (CPU): ~6.3M rollouts/sec peak at n=50,000 (results/bench.json, regenerated after the decision-core fix).</a:t>
             </a:r>
           </a:p>
           <a:p>
@@ -5410,7 +5428,7 @@
                   <a:srgbClr val="141E36"/>
                 </a:solidFill>
               </a:rPr>
-              <a:t>•  The simulator's 12–44% LLM violation claim was disproven by our own experiment (0/94, upper bound 3.1%).</a:t>
+              <a:t>•  The simulator's violation claim (12–44% historically; 20–40% in the current artefact) was disproven by our own experiment (0/94, upper bound 3.1%).</a:t>
             </a:r>
           </a:p>
           <a:p>

</xml_diff>

<commit_message>
docs: rebuild the deck and add the recording checklist
The eight-slide deck is generated from the submission outline and the
result files. A preflight script, a demo runbook, and a lablab form sheet
cover the steps that do not need a live account. The image is pinned and
runs as a non-root user; compose still starts when .env is absent.

Co-authored-by: Hao En Fu <Fu93@users.noreply.github.com>
</commit_message>
<xml_diff>
--- a/results/pitch.pptx
+++ b/results/pitch.pptx
@@ -13,10 +13,8 @@
     <p:sldId id="261" r:id="rId12"/>
     <p:sldId id="262" r:id="rId13"/>
     <p:sldId id="263" r:id="rId14"/>
-    <p:sldId id="264" r:id="rId15"/>
-    <p:sldId id="265" r:id="rId16"/>
   </p:sldIdLst>
-  <p:sldSz cx="12191695" cy="6858000" type="screen4x3"/>
+  <p:sldSz cx="12192000" cy="6858000" type="screen4x3"/>
   <p:notesSz cx="6858000" cy="9144000"/>
   <p:defaultTextStyle>
     <a:defPPr>
@@ -3106,13 +3104,13 @@
         <p:spPr>
           <a:xfrm>
             <a:off x="0" y="0"/>
-            <a:ext cx="12191695" cy="1005840"/>
+            <a:ext cx="12192000" cy="960120"/>
           </a:xfrm>
           <a:prstGeom prst="rect">
             <a:avLst/>
           </a:prstGeom>
           <a:solidFill>
-            <a:srgbClr val="0B1020"/>
+            <a:srgbClr val="1E3A4C"/>
           </a:solidFill>
           <a:ln>
             <a:noFill/>
@@ -3142,20 +3140,154 @@
       </p:sp>
       <p:sp>
         <p:nvSpPr>
-          <p:cNvPr id="3" name="Oval 2"/>
+          <p:cNvPr id="3" name="TextBox 2"/>
+          <p:cNvSpPr txBox="1"/>
+          <p:nvPr/>
+        </p:nvSpPr>
+        <p:spPr>
+          <a:xfrm>
+            <a:off x="411480" y="201168"/>
+            <a:ext cx="11369040" cy="640080"/>
+          </a:xfrm>
+          <a:prstGeom prst="rect">
+            <a:avLst/>
+          </a:prstGeom>
+          <a:noFill/>
+        </p:spPr>
+        <p:txBody>
+          <a:bodyPr wrap="none">
+            <a:spAutoFit/>
+          </a:bodyPr>
+          <a:lstStyle/>
+          <a:p>
+            <a:r>
+              <a:rPr sz="2800" b="1">
+                <a:solidFill>
+                  <a:srgbClr val="FBF7F0"/>
+                </a:solidFill>
+              </a:rPr>
+              <a:t>1. Title</a:t>
+            </a:r>
+          </a:p>
+        </p:txBody>
+      </p:sp>
+      <p:sp>
+        <p:nvSpPr>
+          <p:cNvPr id="4" name="TextBox 3"/>
+          <p:cNvSpPr txBox="1"/>
+          <p:nvPr/>
+        </p:nvSpPr>
+        <p:spPr>
+          <a:xfrm>
+            <a:off x="457200" y="1234440"/>
+            <a:ext cx="11277600" cy="5394960"/>
+          </a:xfrm>
+          <a:prstGeom prst="rect">
+            <a:avLst/>
+          </a:prstGeom>
+          <a:noFill/>
+        </p:spPr>
+        <p:txBody>
+          <a:bodyPr wrap="square">
+            <a:spAutoFit/>
+          </a:bodyPr>
+          <a:lstStyle/>
+          <a:p>
+            <a:pPr>
+              <a:spcAft>
+                <a:spcPts val="1000"/>
+              </a:spcAft>
+            </a:pPr>
+            <a:r>
+              <a:rPr sz="1600">
+                <a:solidFill>
+                  <a:srgbClr val="1C1712"/>
+                </a:solidFill>
+              </a:rPr>
+              <a:t>TradeFlow AI. Track: Reinvent Commerce.</a:t>
+            </a:r>
+          </a:p>
+          <a:p>
+            <a:pPr>
+              <a:spcAft>
+                <a:spcPts val="1000"/>
+              </a:spcAft>
+            </a:pPr>
+            <a:r>
+              <a:rPr sz="1600">
+                <a:solidFill>
+                  <a:srgbClr val="1C1712"/>
+                </a:solidFill>
+              </a:rPr>
+              <a:t>One operator. The engine sets the price. A human sends the offer.</a:t>
+            </a:r>
+          </a:p>
+          <a:p>
+            <a:pPr>
+              <a:spcAft>
+                <a:spcPts val="1000"/>
+              </a:spcAft>
+            </a:pPr>
+            <a:r>
+              <a:rPr sz="1600">
+                <a:solidFill>
+                  <a:srgbClr val="1C1712"/>
+                </a:solidFill>
+              </a:rPr>
+              <a:t>Prototype. No factory has closed a deal through this.</a:t>
+            </a:r>
+          </a:p>
+          <a:p>
+            <a:pPr>
+              <a:spcAft>
+                <a:spcPts val="1000"/>
+              </a:spcAft>
+            </a:pPr>
+            <a:r>
+              <a:rPr sz="1600">
+                <a:solidFill>
+                  <a:srgbClr val="1C1712"/>
+                </a:solidFill>
+              </a:rPr>
+              <a:t>Public repo: https://github.com/Fu93/tradeflow-ai. License: MIT.</a:t>
+            </a:r>
+          </a:p>
+        </p:txBody>
+      </p:sp>
+    </p:spTree>
+  </p:cSld>
+  <p:clrMapOvr>
+    <a:masterClrMapping/>
+  </p:clrMapOvr>
+</p:sld>
+</file>
+
+<file path=ppt/slides/slide2.xml><?xml version="1.0" encoding="utf-8"?>
+<p:sld xmlns:a="http://schemas.openxmlformats.org/drawingml/2006/main" xmlns:p="http://schemas.openxmlformats.org/presentationml/2006/main" xmlns:r="http://schemas.openxmlformats.org/officeDocument/2006/relationships">
+  <p:cSld>
+    <p:spTree>
+      <p:nvGrpSpPr>
+        <p:cNvPr id="1" name=""/>
+        <p:cNvGrpSpPr/>
+        <p:nvPr/>
+      </p:nvGrpSpPr>
+      <p:grpSpPr/>
+      <p:sp>
+        <p:nvSpPr>
+          <p:cNvPr id="2" name="Rectangle 1"/>
           <p:cNvSpPr/>
           <p:nvPr/>
         </p:nvSpPr>
         <p:spPr>
           <a:xfrm>
-            <a:off x="365760" y="320040"/>
-            <a:ext cx="228600" cy="228600"/>
+            <a:off x="0" y="0"/>
+            <a:ext cx="12192000" cy="960120"/>
           </a:xfrm>
-          <a:prstGeom prst="ellipse">
+          <a:prstGeom prst="rect">
             <a:avLst/>
           </a:prstGeom>
           <a:solidFill>
-            <a:srgbClr val="2C6FB5"/>
+            <a:srgbClr val="1E3A4C"/>
           </a:solidFill>
           <a:ln>
             <a:noFill/>
@@ -3185,14 +3317,14 @@
       </p:sp>
       <p:sp>
         <p:nvSpPr>
-          <p:cNvPr id="4" name="TextBox 3"/>
+          <p:cNvPr id="3" name="TextBox 2"/>
           <p:cNvSpPr txBox="1"/>
           <p:nvPr/>
         </p:nvSpPr>
         <p:spPr>
           <a:xfrm>
-            <a:off x="731520" y="201168"/>
-            <a:ext cx="11094415" cy="731520"/>
+            <a:off x="411480" y="201168"/>
+            <a:ext cx="11369040" cy="640080"/>
           </a:xfrm>
           <a:prstGeom prst="rect">
             <a:avLst/>
@@ -3200,32 +3332,32 @@
           <a:noFill/>
         </p:spPr>
         <p:txBody>
-          <a:bodyPr wrap="none" tIns="0" bIns="0">
+          <a:bodyPr wrap="none">
             <a:spAutoFit/>
           </a:bodyPr>
           <a:lstStyle/>
           <a:p>
             <a:r>
-              <a:rPr sz="3000" b="1">
-                <a:solidFill>
-                  <a:srgbClr val="FFFFFF"/>
+              <a:rPr sz="2800" b="1">
+                <a:solidFill>
+                  <a:srgbClr val="FBF7F0"/>
                 </a:solidFill>
               </a:rPr>
-              <a:t>TradeFlow AI</a:t>
-            </a:r>
-          </a:p>
-        </p:txBody>
-      </p:sp>
-      <p:sp>
-        <p:nvSpPr>
-          <p:cNvPr id="5" name="TextBox 4"/>
+              <a:t>2. Problem</a:t>
+            </a:r>
+          </a:p>
+        </p:txBody>
+      </p:sp>
+      <p:sp>
+        <p:nvSpPr>
+          <p:cNvPr id="4" name="TextBox 3"/>
           <p:cNvSpPr txBox="1"/>
           <p:nvPr/>
         </p:nvSpPr>
         <p:spPr>
           <a:xfrm>
-            <a:off x="548640" y="1325880"/>
-            <a:ext cx="11094415" cy="5303520"/>
+            <a:off x="457200" y="1234440"/>
+            <a:ext cx="11277600" cy="5394960"/>
           </a:xfrm>
           <a:prstGeom prst="rect">
             <a:avLst/>
@@ -3233,78 +3365,53 @@
           <a:noFill/>
         </p:spPr>
         <p:txBody>
-          <a:bodyPr wrap="square" tIns="0" lIns="0" rIns="0"/>
+          <a:bodyPr wrap="square">
+            <a:spAutoFit/>
+          </a:bodyPr>
           <a:lstStyle/>
           <a:p>
             <a:pPr>
-              <a:spcBef>
-                <a:spcPts val="0"/>
-              </a:spcBef>
               <a:spcAft>
-                <a:spcPts val="800"/>
+                <a:spcPts val="1000"/>
               </a:spcAft>
             </a:pPr>
             <a:r>
-              <a:rPr sz="1400">
-                <a:solidFill>
-                  <a:srgbClr val="141E36"/>
+              <a:rPr sz="1600">
+                <a:solidFill>
+                  <a:srgbClr val="1C1712"/>
                 </a:solidFill>
               </a:rPr>
-              <a:t>•  Constrained Decision Prototype: Vectorized Expectimax &amp; AST Guardrails.</a:t>
+              <a:t>Cross-border buyers either negotiate alone, often with a language penalty, or pay an agent.</a:t>
             </a:r>
           </a:p>
           <a:p>
             <a:pPr>
-              <a:spcBef>
-                <a:spcPts val="0"/>
-              </a:spcBef>
               <a:spcAft>
-                <a:spcPts val="800"/>
+                <a:spcPts val="1000"/>
               </a:spcAft>
             </a:pPr>
             <a:r>
-              <a:rPr sz="1400">
-                <a:solidFill>
-                  <a:srgbClr val="141E36"/>
+              <a:rPr sz="1600">
+                <a:solidFill>
+                  <a:srgbClr val="1C1712"/>
                 </a:solidFill>
               </a:rPr>
-              <a:t>•  Decision core computes; the LLM only renders language.</a:t>
+              <a:t>TradeFlow is a prototype of a third arrangement: one operator, software doing the arithmetic, the person keeping the send button.</a:t>
             </a:r>
           </a:p>
           <a:p>
             <a:pPr>
-              <a:spcBef>
-                <a:spcPts val="0"/>
-              </a:spcBef>
               <a:spcAft>
-                <a:spcPts val="800"/>
+                <a:spcPts val="1000"/>
               </a:spcAft>
             </a:pPr>
             <a:r>
-              <a:rPr sz="1400">
-                <a:solidFill>
-                  <a:srgbClr val="141E36"/>
+              <a:rPr sz="1600">
+                <a:solidFill>
+                  <a:srgbClr val="1C1712"/>
                 </a:solidFill>
               </a:rPr>
-              <a:t>•  AMD Developer Hackathon: ACT III</a:t>
-            </a:r>
-          </a:p>
-          <a:p>
-            <a:pPr>
-              <a:spcBef>
-                <a:spcPts val="0"/>
-              </a:spcBef>
-              <a:spcAft>
-                <a:spcPts val="800"/>
-              </a:spcAft>
-            </a:pPr>
-            <a:r>
-              <a:rPr sz="1400">
-                <a:solidFill>
-                  <a:srgbClr val="141E36"/>
-                </a:solidFill>
-              </a:rPr>
-              <a:t>•  Reinvent Commerce + Evolus Business Agents on AMD</a:t>
+              <a:t>It is not a deployed company and it has not bought from a real factory.</a:t>
             </a:r>
           </a:p>
         </p:txBody>
@@ -3317,7 +3424,7 @@
 </p:sld>
 </file>
 
-<file path=ppt/slides/slide10.xml><?xml version="1.0" encoding="utf-8"?>
+<file path=ppt/slides/slide3.xml><?xml version="1.0" encoding="utf-8"?>
 <p:sld xmlns:a="http://schemas.openxmlformats.org/drawingml/2006/main" xmlns:p="http://schemas.openxmlformats.org/presentationml/2006/main" xmlns:r="http://schemas.openxmlformats.org/officeDocument/2006/relationships">
   <p:cSld>
     <p:spTree>
@@ -3336,13 +3443,13 @@
         <p:spPr>
           <a:xfrm>
             <a:off x="0" y="0"/>
-            <a:ext cx="12191695" cy="1005840"/>
+            <a:ext cx="12192000" cy="960120"/>
           </a:xfrm>
           <a:prstGeom prst="rect">
             <a:avLst/>
           </a:prstGeom>
           <a:solidFill>
-            <a:srgbClr val="0B1020"/>
+            <a:srgbClr val="1E3A4C"/>
           </a:solidFill>
           <a:ln>
             <a:noFill/>
@@ -3372,20 +3479,154 @@
       </p:sp>
       <p:sp>
         <p:nvSpPr>
-          <p:cNvPr id="3" name="Oval 2"/>
+          <p:cNvPr id="3" name="TextBox 2"/>
+          <p:cNvSpPr txBox="1"/>
+          <p:nvPr/>
+        </p:nvSpPr>
+        <p:spPr>
+          <a:xfrm>
+            <a:off x="411480" y="201168"/>
+            <a:ext cx="11369040" cy="640080"/>
+          </a:xfrm>
+          <a:prstGeom prst="rect">
+            <a:avLst/>
+          </a:prstGeom>
+          <a:noFill/>
+        </p:spPr>
+        <p:txBody>
+          <a:bodyPr wrap="none">
+            <a:spAutoFit/>
+          </a:bodyPr>
+          <a:lstStyle/>
+          <a:p>
+            <a:r>
+              <a:rPr sz="2800" b="1">
+                <a:solidFill>
+                  <a:srgbClr val="FBF7F0"/>
+                </a:solidFill>
+              </a:rPr>
+              <a:t>3. Split</a:t>
+            </a:r>
+          </a:p>
+        </p:txBody>
+      </p:sp>
+      <p:sp>
+        <p:nvSpPr>
+          <p:cNvPr id="4" name="TextBox 3"/>
+          <p:cNvSpPr txBox="1"/>
+          <p:nvPr/>
+        </p:nvSpPr>
+        <p:spPr>
+          <a:xfrm>
+            <a:off x="457200" y="1234440"/>
+            <a:ext cx="11277600" cy="5394960"/>
+          </a:xfrm>
+          <a:prstGeom prst="rect">
+            <a:avLst/>
+          </a:prstGeom>
+          <a:noFill/>
+        </p:spPr>
+        <p:txBody>
+          <a:bodyPr wrap="square">
+            <a:spAutoFit/>
+          </a:bodyPr>
+          <a:lstStyle/>
+          <a:p>
+            <a:pPr>
+              <a:spcAft>
+                <a:spcPts val="1000"/>
+              </a:spcAft>
+            </a:pPr>
+            <a:r>
+              <a:rPr sz="1600">
+                <a:solidFill>
+                  <a:srgbClr val="1C1712"/>
+                </a:solidFill>
+              </a:rPr>
+              <a:t>Solver decides. The decision core does not ask a language model what to pay.</a:t>
+            </a:r>
+          </a:p>
+          <a:p>
+            <a:pPr>
+              <a:spcAft>
+                <a:spcPts val="1000"/>
+              </a:spcAft>
+            </a:pPr>
+            <a:r>
+              <a:rPr sz="1600">
+                <a:solidFill>
+                  <a:srgbClr val="1C1712"/>
+                </a:solidFill>
+              </a:rPr>
+              <a:t>Model phrases. An optional call can classify a message or draft wording.</a:t>
+            </a:r>
+          </a:p>
+          <a:p>
+            <a:pPr>
+              <a:spcAft>
+                <a:spcPts val="1000"/>
+              </a:spcAft>
+            </a:pPr>
+            <a:r>
+              <a:rPr sz="1600">
+                <a:solidFill>
+                  <a:srgbClr val="1C1712"/>
+                </a:solidFill>
+              </a:rPr>
+              <a:t>Human sends. The Chrome extension (Manifest V3) shows a card. It cannot press Send.</a:t>
+            </a:r>
+          </a:p>
+          <a:p>
+            <a:pPr>
+              <a:spcAft>
+                <a:spcPts val="1000"/>
+              </a:spcAft>
+            </a:pPr>
+            <a:r>
+              <a:rPr sz="1600">
+                <a:solidFill>
+                  <a:srgbClr val="1C1712"/>
+                </a:solidFill>
+              </a:rPr>
+              <a:t>Code: src/engine/solver.py, src/engine/multi_solver.py, extension/.</a:t>
+            </a:r>
+          </a:p>
+        </p:txBody>
+      </p:sp>
+    </p:spTree>
+  </p:cSld>
+  <p:clrMapOvr>
+    <a:masterClrMapping/>
+  </p:clrMapOvr>
+</p:sld>
+</file>
+
+<file path=ppt/slides/slide4.xml><?xml version="1.0" encoding="utf-8"?>
+<p:sld xmlns:a="http://schemas.openxmlformats.org/drawingml/2006/main" xmlns:p="http://schemas.openxmlformats.org/presentationml/2006/main" xmlns:r="http://schemas.openxmlformats.org/officeDocument/2006/relationships">
+  <p:cSld>
+    <p:spTree>
+      <p:nvGrpSpPr>
+        <p:cNvPr id="1" name=""/>
+        <p:cNvGrpSpPr/>
+        <p:nvPr/>
+      </p:nvGrpSpPr>
+      <p:grpSpPr/>
+      <p:sp>
+        <p:nvSpPr>
+          <p:cNvPr id="2" name="Rectangle 1"/>
           <p:cNvSpPr/>
           <p:nvPr/>
         </p:nvSpPr>
         <p:spPr>
           <a:xfrm>
-            <a:off x="365760" y="320040"/>
-            <a:ext cx="228600" cy="228600"/>
+            <a:off x="0" y="0"/>
+            <a:ext cx="12192000" cy="960120"/>
           </a:xfrm>
-          <a:prstGeom prst="ellipse">
+          <a:prstGeom prst="rect">
             <a:avLst/>
           </a:prstGeom>
           <a:solidFill>
-            <a:srgbClr val="2C6FB5"/>
+            <a:srgbClr val="1E3A4C"/>
           </a:solidFill>
           <a:ln>
             <a:noFill/>
@@ -3415,14 +3656,14 @@
       </p:sp>
       <p:sp>
         <p:nvSpPr>
-          <p:cNvPr id="4" name="TextBox 3"/>
+          <p:cNvPr id="3" name="TextBox 2"/>
           <p:cNvSpPr txBox="1"/>
           <p:nvPr/>
         </p:nvSpPr>
         <p:spPr>
           <a:xfrm>
-            <a:off x="731520" y="201168"/>
-            <a:ext cx="11094415" cy="731520"/>
+            <a:off x="411480" y="201168"/>
+            <a:ext cx="11369040" cy="640080"/>
           </a:xfrm>
           <a:prstGeom prst="rect">
             <a:avLst/>
@@ -3430,32 +3671,32 @@
           <a:noFill/>
         </p:spPr>
         <p:txBody>
-          <a:bodyPr wrap="none" tIns="0" bIns="0">
+          <a:bodyPr wrap="none">
             <a:spAutoFit/>
           </a:bodyPr>
           <a:lstStyle/>
           <a:p>
             <a:r>
-              <a:rPr sz="3000" b="1">
-                <a:solidFill>
-                  <a:srgbClr val="FFFFFF"/>
+              <a:rPr sz="2800" b="1">
+                <a:solidFill>
+                  <a:srgbClr val="FBF7F0"/>
                 </a:solidFill>
               </a:rPr>
-              <a:t>Next steps</a:t>
-            </a:r>
-          </a:p>
-        </p:txBody>
-      </p:sp>
-      <p:sp>
-        <p:nvSpPr>
-          <p:cNvPr id="5" name="TextBox 4"/>
+              <a:t>4. Decision core</a:t>
+            </a:r>
+          </a:p>
+        </p:txBody>
+      </p:sp>
+      <p:sp>
+        <p:nvSpPr>
+          <p:cNvPr id="4" name="TextBox 3"/>
           <p:cNvSpPr txBox="1"/>
           <p:nvPr/>
         </p:nvSpPr>
         <p:spPr>
           <a:xfrm>
-            <a:off x="548640" y="1325880"/>
-            <a:ext cx="11094415" cy="5303520"/>
+            <a:off x="457200" y="1234440"/>
+            <a:ext cx="11277600" cy="5394960"/>
           </a:xfrm>
           <a:prstGeom prst="rect">
             <a:avLst/>
@@ -3463,96 +3704,53 @@
           <a:noFill/>
         </p:spPr>
         <p:txBody>
-          <a:bodyPr wrap="square" tIns="0" lIns="0" rIns="0"/>
+          <a:bodyPr wrap="square">
+            <a:spAutoFit/>
+          </a:bodyPr>
           <a:lstStyle/>
           <a:p>
             <a:pPr>
-              <a:spcBef>
-                <a:spcPts val="0"/>
-              </a:spcBef>
               <a:spcAft>
-                <a:spcPts val="800"/>
+                <a:spcPts val="1000"/>
               </a:spcAft>
             </a:pPr>
             <a:r>
-              <a:rPr sz="1400">
-                <a:solidFill>
-                  <a:srgbClr val="141E36"/>
+              <a:rPr sz="1600">
+                <a:solidFill>
+                  <a:srgbClr val="1C1712"/>
                 </a:solidFill>
               </a:rPr>
-              <a:t>•  Collect 10,000+ real negotiation logs to fit the priors properly (currently chosen, not calibrated).</a:t>
+              <a:t>A belief about the supplier reserve, then a vectorised Expectimax search over openings and concession curves.</a:t>
             </a:r>
           </a:p>
           <a:p>
             <a:pPr>
-              <a:spcBef>
-                <a:spcPts val="0"/>
-              </a:spcBef>
               <a:spcAft>
-                <a:spcPts val="800"/>
+                <a:spcPts val="1000"/>
               </a:spcAft>
             </a:pPr>
             <a:r>
-              <a:rPr sz="1400">
-                <a:solidFill>
-                  <a:srgbClr val="141E36"/>
+              <a:rPr sz="1600">
+                <a:solidFill>
+                  <a:srgbClr val="1C1712"/>
                 </a:solidFill>
               </a:rPr>
-              <a:t>•  If AMD Developer Cloud credits are granted: obtain a real MI300X measurement to replace the roofline bound.</a:t>
+              <a:t>Read the recommended price and the breakdown probability off the dashboard you just captured.</a:t>
             </a:r>
           </a:p>
           <a:p>
             <a:pPr>
-              <a:spcBef>
-                <a:spcPts val="0"/>
-              </a:spcBef>
               <a:spcAft>
-                <a:spcPts val="800"/>
+                <a:spcPts val="1000"/>
               </a:spcAft>
             </a:pPr>
             <a:r>
-              <a:rPr sz="1400">
-                <a:solidFill>
-                  <a:srgbClr val="141E36"/>
+              <a:rPr sz="1600">
+                <a:solidFill>
+                  <a:srgbClr val="1C1712"/>
                 </a:solidFill>
               </a:rPr>
-              <a:t>•  Rotate the two API keys exposed in plaintext during development.</a:t>
-            </a:r>
-          </a:p>
-          <a:p>
-            <a:pPr>
-              <a:spcBef>
-                <a:spcPts val="0"/>
-              </a:spcBef>
-              <a:spcAft>
-                <a:spcPts val="800"/>
-              </a:spcAft>
-            </a:pPr>
-            <a:r>
-              <a:rPr sz="1400">
-                <a:solidFill>
-                  <a:srgbClr val="141E36"/>
-                </a:solidFill>
-              </a:rPr>
-              <a:t>•  Extend the real-model benchmark beyond 100 matches to tighten the confidence bound.</a:t>
-            </a:r>
-          </a:p>
-          <a:p>
-            <a:pPr>
-              <a:spcBef>
-                <a:spcPts val="0"/>
-              </a:spcBef>
-              <a:spcAft>
-                <a:spcPts val="800"/>
-              </a:spcAft>
-            </a:pPr>
-            <a:r>
-              <a:rPr sz="1400">
-                <a:solidFill>
-                  <a:srgbClr val="141E36"/>
-                </a:solidFill>
-              </a:rPr>
-              <a:t>•  Double-track submission: Reinvent Commerce (main) + Evolus Business Agents on AMD.</a:t>
+              <a:t>This slide does not state a latency. Use the number on the screen.</a:t>
             </a:r>
           </a:p>
         </p:txBody>
@@ -3565,7 +3763,7 @@
 </p:sld>
 </file>
 
-<file path=ppt/slides/slide2.xml><?xml version="1.0" encoding="utf-8"?>
+<file path=ppt/slides/slide5.xml><?xml version="1.0" encoding="utf-8"?>
 <p:sld xmlns:a="http://schemas.openxmlformats.org/drawingml/2006/main" xmlns:p="http://schemas.openxmlformats.org/presentationml/2006/main" xmlns:r="http://schemas.openxmlformats.org/officeDocument/2006/relationships">
   <p:cSld>
     <p:spTree>
@@ -3584,13 +3782,13 @@
         <p:spPr>
           <a:xfrm>
             <a:off x="0" y="0"/>
-            <a:ext cx="12191695" cy="1005840"/>
+            <a:ext cx="12192000" cy="960120"/>
           </a:xfrm>
           <a:prstGeom prst="rect">
             <a:avLst/>
           </a:prstGeom>
           <a:solidFill>
-            <a:srgbClr val="0B1020"/>
+            <a:srgbClr val="1E3A4C"/>
           </a:solidFill>
           <a:ln>
             <a:noFill/>
@@ -3620,20 +3818,139 @@
       </p:sp>
       <p:sp>
         <p:nvSpPr>
-          <p:cNvPr id="3" name="Oval 2"/>
+          <p:cNvPr id="3" name="TextBox 2"/>
+          <p:cNvSpPr txBox="1"/>
+          <p:nvPr/>
+        </p:nvSpPr>
+        <p:spPr>
+          <a:xfrm>
+            <a:off x="411480" y="201168"/>
+            <a:ext cx="11369040" cy="640080"/>
+          </a:xfrm>
+          <a:prstGeom prst="rect">
+            <a:avLst/>
+          </a:prstGeom>
+          <a:noFill/>
+        </p:spPr>
+        <p:txBody>
+          <a:bodyPr wrap="none">
+            <a:spAutoFit/>
+          </a:bodyPr>
+          <a:lstStyle/>
+          <a:p>
+            <a:r>
+              <a:rPr sz="2800" b="1">
+                <a:solidFill>
+                  <a:srgbClr val="FBF7F0"/>
+                </a:solidFill>
+              </a:rPr>
+              <a:t>5. AMD language layer</a:t>
+            </a:r>
+          </a:p>
+        </p:txBody>
+      </p:sp>
+      <p:sp>
+        <p:nvSpPr>
+          <p:cNvPr id="4" name="TextBox 3"/>
+          <p:cNvSpPr txBox="1"/>
+          <p:nvPr/>
+        </p:nvSpPr>
+        <p:spPr>
+          <a:xfrm>
+            <a:off x="457200" y="1234440"/>
+            <a:ext cx="11277600" cy="5394960"/>
+          </a:xfrm>
+          <a:prstGeom prst="rect">
+            <a:avLst/>
+          </a:prstGeom>
+          <a:noFill/>
+        </p:spPr>
+        <p:txBody>
+          <a:bodyPr wrap="square">
+            <a:spAutoFit/>
+          </a:bodyPr>
+          <a:lstStyle/>
+          <a:p>
+            <a:pPr>
+              <a:spcAft>
+                <a:spcPts val="1000"/>
+              </a:spcAft>
+            </a:pPr>
+            <a:r>
+              <a:rPr sz="1600">
+                <a:solidFill>
+                  <a:srgbClr val="1C1712"/>
+                </a:solidFill>
+              </a:rPr>
+              <a:t>Sample endpoint: https://developer.amd.com.cn/radeon/api/v1.</a:t>
+            </a:r>
+          </a:p>
+          <a:p>
+            <a:pPr>
+              <a:spcAft>
+                <a:spcPts val="1000"/>
+              </a:spcAft>
+            </a:pPr>
+            <a:r>
+              <a:rPr sz="1600">
+                <a:solidFill>
+                  <a:srgbClr val="1C1712"/>
+                </a:solidFill>
+              </a:rPr>
+              <a:t>Committed log results/real_llm_benchmark_100.json (2026-10-15): model Qwen3.8-Flash-Next, 348 calls, average latency 16.81 s, cost $0.108444.</a:t>
+            </a:r>
+          </a:p>
+          <a:p>
+            <a:pPr>
+              <a:spcAft>
+                <a:spcPts val="1000"/>
+              </a:spcAft>
+            </a:pPr>
+            <a:r>
+              <a:rPr sz="1600">
+                <a:solidFill>
+                  <a:srgbClr val="1C1712"/>
+                </a:solidFill>
+              </a:rPr>
+              <a:t>That file does not store an HTTP status. status: ok from scripts/verify_amd_endpoint.py means that process received HTTP 200. skipped_no_credentials is not a successful check.</a:t>
+            </a:r>
+          </a:p>
+        </p:txBody>
+      </p:sp>
+    </p:spTree>
+  </p:cSld>
+  <p:clrMapOvr>
+    <a:masterClrMapping/>
+  </p:clrMapOvr>
+</p:sld>
+</file>
+
+<file path=ppt/slides/slide6.xml><?xml version="1.0" encoding="utf-8"?>
+<p:sld xmlns:a="http://schemas.openxmlformats.org/drawingml/2006/main" xmlns:p="http://schemas.openxmlformats.org/presentationml/2006/main" xmlns:r="http://schemas.openxmlformats.org/officeDocument/2006/relationships">
+  <p:cSld>
+    <p:spTree>
+      <p:nvGrpSpPr>
+        <p:cNvPr id="1" name=""/>
+        <p:cNvGrpSpPr/>
+        <p:nvPr/>
+      </p:nvGrpSpPr>
+      <p:grpSpPr/>
+      <p:sp>
+        <p:nvSpPr>
+          <p:cNvPr id="2" name="Rectangle 1"/>
           <p:cNvSpPr/>
           <p:nvPr/>
         </p:nvSpPr>
         <p:spPr>
           <a:xfrm>
-            <a:off x="365760" y="320040"/>
-            <a:ext cx="228600" cy="228600"/>
+            <a:off x="0" y="0"/>
+            <a:ext cx="12192000" cy="960120"/>
           </a:xfrm>
-          <a:prstGeom prst="ellipse">
+          <a:prstGeom prst="rect">
             <a:avLst/>
           </a:prstGeom>
           <a:solidFill>
-            <a:srgbClr val="2C6FB5"/>
+            <a:srgbClr val="1E3A4C"/>
           </a:solidFill>
           <a:ln>
             <a:noFill/>
@@ -3663,14 +3980,14 @@
       </p:sp>
       <p:sp>
         <p:nvSpPr>
-          <p:cNvPr id="4" name="TextBox 3"/>
+          <p:cNvPr id="3" name="TextBox 2"/>
           <p:cNvSpPr txBox="1"/>
           <p:nvPr/>
         </p:nvSpPr>
         <p:spPr>
           <a:xfrm>
-            <a:off x="731520" y="201168"/>
-            <a:ext cx="11094415" cy="731520"/>
+            <a:off x="411480" y="201168"/>
+            <a:ext cx="11369040" cy="640080"/>
           </a:xfrm>
           <a:prstGeom prst="rect">
             <a:avLst/>
@@ -3678,32 +3995,32 @@
           <a:noFill/>
         </p:spPr>
         <p:txBody>
-          <a:bodyPr wrap="none" tIns="0" bIns="0">
+          <a:bodyPr wrap="none">
             <a:spAutoFit/>
           </a:bodyPr>
           <a:lstStyle/>
           <a:p>
             <a:r>
-              <a:rPr sz="3000" b="1">
-                <a:solidFill>
-                  <a:srgbClr val="FFFFFF"/>
+              <a:rPr sz="2800" b="1">
+                <a:solidFill>
+                  <a:srgbClr val="FBF7F0"/>
                 </a:solidFill>
               </a:rPr>
-              <a:t>One-liner: an AI-native trading company of one</a:t>
-            </a:r>
-          </a:p>
-        </p:txBody>
-      </p:sp>
-      <p:sp>
-        <p:nvSpPr>
-          <p:cNvPr id="5" name="TextBox 4"/>
+              <a:t>6. AMD compute layer</a:t>
+            </a:r>
+          </a:p>
+        </p:txBody>
+      </p:sp>
+      <p:sp>
+        <p:nvSpPr>
+          <p:cNvPr id="4" name="TextBox 3"/>
           <p:cNvSpPr txBox="1"/>
           <p:nvPr/>
         </p:nvSpPr>
         <p:spPr>
           <a:xfrm>
-            <a:off x="548640" y="1325880"/>
-            <a:ext cx="11094415" cy="5303520"/>
+            <a:off x="457200" y="1234440"/>
+            <a:ext cx="11277600" cy="5394960"/>
           </a:xfrm>
           <a:prstGeom prst="rect">
             <a:avLst/>
@@ -3711,78 +4028,83 @@
           <a:noFill/>
         </p:spPr>
         <p:txBody>
-          <a:bodyPr wrap="square" tIns="0" lIns="0" rIns="0"/>
+          <a:bodyPr wrap="square">
+            <a:spAutoFit/>
+          </a:bodyPr>
           <a:lstStyle/>
           <a:p>
             <a:pPr>
-              <a:spcBef>
-                <a:spcPts val="0"/>
-              </a:spcBef>
               <a:spcAft>
-                <a:spcPts val="800"/>
+                <a:spcPts val="1000"/>
               </a:spcAft>
             </a:pPr>
             <a:r>
-              <a:rPr sz="1400">
-                <a:solidFill>
-                  <a:srgbClr val="141E36"/>
+              <a:rPr sz="1600">
+                <a:solidFill>
+                  <a:srgbClr val="1C1712"/>
                 </a:solidFill>
               </a:rPr>
-              <a:t>•  TradeFlow computes concession strategies with Vectorized Expectimax + AST code guardrails.</a:t>
+              <a:t>TRADEFLOW_SOLVER_BACKEND selects NumPy (default) or a CuPy/ROCm request.</a:t>
             </a:r>
           </a:p>
           <a:p>
             <a:pPr>
-              <a:spcBef>
-                <a:spcPts val="0"/>
-              </a:spcBef>
               <a:spcAft>
-                <a:spcPts val="800"/>
+                <a:spcPts val="1000"/>
               </a:spcAft>
             </a:pPr>
             <a:r>
-              <a:rPr sz="1400">
-                <a:solidFill>
-                  <a:srgbClr val="141E36"/>
+              <a:rPr sz="1600">
+                <a:solidFill>
+                  <a:srgbClr val="1C1712"/>
                 </a:solidFill>
               </a:rPr>
-              <a:t>•  'Math governs strategy, LLM expresses jargon.'</a:t>
+              <a:t>results/bench.json is a CPU measurement (is_gpu_active: false).</a:t>
             </a:r>
           </a:p>
           <a:p>
             <a:pPr>
-              <a:spcBef>
-                <a:spcPts val="0"/>
-              </a:spcBef>
               <a:spcAft>
-                <a:spcPts val="800"/>
+                <a:spcPts val="1000"/>
               </a:spcAft>
             </a:pPr>
             <a:r>
-              <a:rPr sz="1400">
-                <a:solidFill>
-                  <a:srgbClr val="141E36"/>
+              <a:rPr sz="1600">
+                <a:solidFill>
+                  <a:srgbClr val="1C1712"/>
                 </a:solidFill>
               </a:rPr>
-              <a:t>•  The LLM never decides a price; it renders an already-computed, AST-validated decision.</a:t>
+              <a:t>The MI300X column is a theoretical roofline lower-bound estimate, not measured.</a:t>
             </a:r>
           </a:p>
           <a:p>
             <a:pPr>
-              <a:spcBef>
-                <a:spcPts val="0"/>
-              </a:spcBef>
               <a:spcAft>
-                <a:spcPts val="800"/>
+                <a:spcPts val="1000"/>
               </a:spcAft>
             </a:pPr>
             <a:r>
-              <a:rPr sz="1400">
-                <a:solidFill>
-                  <a:srgbClr val="141E36"/>
+              <a:rPr sz="1600">
+                <a:solidFill>
+                  <a:srgbClr val="1C1712"/>
                 </a:solidFill>
               </a:rPr>
-              <a:t>•  One operator can run supplier-facing procurement that traditionally needs a sourcing team.</a:t>
+              <a:t>Formula: lower_bound_seconds = (working_set_mb * 1024 * 1024) / (5.3e12).</a:t>
+            </a:r>
+          </a:p>
+          <a:p>
+            <a:pPr>
+              <a:spcAft>
+                <a:spcPts val="1000"/>
+              </a:spcAft>
+            </a:pPr>
+            <a:r>
+              <a:rPr sz="1600">
+                <a:solidFill>
+                  <a:srgbClr val="1C1712"/>
+                </a:solidFill>
+              </a:rPr>
+              <a:t>No AMD GPU measurement is in the repo unless a sibling benchmark JSON says ran_on_amd_gpu: true. Do not narrate a speedup.</a:t>
             </a:r>
           </a:p>
         </p:txBody>
@@ -3795,7 +4117,7 @@
 </p:sld>
 </file>
 
-<file path=ppt/slides/slide3.xml><?xml version="1.0" encoding="utf-8"?>
+<file path=ppt/slides/slide7.xml><?xml version="1.0" encoding="utf-8"?>
 <p:sld xmlns:a="http://schemas.openxmlformats.org/drawingml/2006/main" xmlns:p="http://schemas.openxmlformats.org/presentationml/2006/main" xmlns:r="http://schemas.openxmlformats.org/officeDocument/2006/relationships">
   <p:cSld>
     <p:spTree>
@@ -3814,13 +4136,13 @@
         <p:spPr>
           <a:xfrm>
             <a:off x="0" y="0"/>
-            <a:ext cx="12191695" cy="1005840"/>
+            <a:ext cx="12192000" cy="960120"/>
           </a:xfrm>
           <a:prstGeom prst="rect">
             <a:avLst/>
           </a:prstGeom>
           <a:solidFill>
-            <a:srgbClr val="0B1020"/>
+            <a:srgbClr val="1E3A4C"/>
           </a:solidFill>
           <a:ln>
             <a:noFill/>
@@ -3850,20 +4172,199 @@
       </p:sp>
       <p:sp>
         <p:nvSpPr>
-          <p:cNvPr id="3" name="Oval 2"/>
+          <p:cNvPr id="3" name="TextBox 2"/>
+          <p:cNvSpPr txBox="1"/>
+          <p:nvPr/>
+        </p:nvSpPr>
+        <p:spPr>
+          <a:xfrm>
+            <a:off x="411480" y="201168"/>
+            <a:ext cx="11369040" cy="640080"/>
+          </a:xfrm>
+          <a:prstGeom prst="rect">
+            <a:avLst/>
+          </a:prstGeom>
+          <a:noFill/>
+        </p:spPr>
+        <p:txBody>
+          <a:bodyPr wrap="none">
+            <a:spAutoFit/>
+          </a:bodyPr>
+          <a:lstStyle/>
+          <a:p>
+            <a:r>
+              <a:rPr sz="2800" b="1">
+                <a:solidFill>
+                  <a:srgbClr val="FBF7F0"/>
+                </a:solidFill>
+              </a:rPr>
+              <a:t>7. Evidence, with the baseline named</a:t>
+            </a:r>
+          </a:p>
+        </p:txBody>
+      </p:sp>
+      <p:sp>
+        <p:nvSpPr>
+          <p:cNvPr id="4" name="TextBox 3"/>
+          <p:cNvSpPr txBox="1"/>
+          <p:nvPr/>
+        </p:nvSpPr>
+        <p:spPr>
+          <a:xfrm>
+            <a:off x="457200" y="1234440"/>
+            <a:ext cx="11277600" cy="5394960"/>
+          </a:xfrm>
+          <a:prstGeom prst="rect">
+            <a:avLst/>
+          </a:prstGeom>
+          <a:noFill/>
+        </p:spPr>
+        <p:txBody>
+          <a:bodyPr wrap="square">
+            <a:spAutoFit/>
+          </a:bodyPr>
+          <a:lstStyle/>
+          <a:p>
+            <a:pPr>
+              <a:spcAft>
+                <a:spcPts val="1000"/>
+              </a:spcAft>
+            </a:pPr>
+            <a:r>
+              <a:rPr sz="1600">
+                <a:solidFill>
+                  <a:srgbClr val="1C1712"/>
+                </a:solidFill>
+              </a:rPr>
+              <a:t>Self-play (results/self_play_benchmark.md): engine savings versus that table's walk-away ceiling run from 8.8% to 20.0%. Hard-Bargainer 8.8% versus the fixed baseline 9.2%. 20 matches, 5 archetypes, seed 42. Not the auction headline.</a:t>
+            </a:r>
+          </a:p>
+          <a:p>
+            <a:pPr>
+              <a:spcAft>
+                <a:spcPts val="1000"/>
+              </a:spcAft>
+            </a:pPr>
+            <a:r>
+              <a:rPr sz="1600">
+                <a:solidFill>
+                  <a:srgbClr val="1C1712"/>
+                </a:solidFill>
+              </a:rPr>
+              <a:t>Real-model log, different experiment: Bluffing Hardliner deal rate 61.11%. 0 budget violations in 94 completed matches.</a:t>
+            </a:r>
+          </a:p>
+          <a:p>
+            <a:pPr>
+              <a:spcAft>
+                <a:spcPts val="1000"/>
+              </a:spcAft>
+            </a:pPr>
+            <a:r>
+              <a:rPr sz="1600">
+                <a:solidFill>
+                  <a:srgbClr val="1C1712"/>
+                </a:solidFill>
+              </a:rPr>
+              <a:t>Held-out intent accuracy on the synthetic set: 63.08% (195 of 500 held out).</a:t>
+            </a:r>
+          </a:p>
+          <a:p>
+            <a:pPr>
+              <a:spcAft>
+                <a:spcPts val="1000"/>
+              </a:spcAft>
+            </a:pPr>
+            <a:r>
+              <a:rPr sz="1600">
+                <a:solidFill>
+                  <a:srgbClr val="1C1712"/>
+                </a:solidFill>
+              </a:rPr>
+              <a:t>Auction headline is savings versus the first-round best quote. Versus target is shown, including when that figure is negative. The walk-away ceiling figure is secondary.</a:t>
+            </a:r>
+          </a:p>
+          <a:p>
+            <a:pPr>
+              <a:spcAft>
+                <a:spcPts val="1000"/>
+              </a:spcAft>
+            </a:pPr>
+            <a:r>
+              <a:rPr sz="1600">
+                <a:solidFill>
+                  <a:srgbClr val="1C1712"/>
+                </a:solidFill>
+              </a:rPr>
+              <a:t>Headline savings vs first-round best quote: 5.0% (¥6,600.00 total)</a:t>
+            </a:r>
+          </a:p>
+          <a:p>
+            <a:pPr>
+              <a:spcAft>
+                <a:spcPts val="1000"/>
+              </a:spcAft>
+            </a:pPr>
+            <a:r>
+              <a:rPr sz="1600">
+                <a:solidFill>
+                  <a:srgbClr val="1C1712"/>
+                </a:solidFill>
+              </a:rPr>
+              <a:t>Versus target: -5.0% (¥-6,000.00 total). A negative figure means the settled price is above target.</a:t>
+            </a:r>
+          </a:p>
+          <a:p>
+            <a:pPr>
+              <a:spcAft>
+                <a:spcPts val="1000"/>
+              </a:spcAft>
+            </a:pPr>
+            <a:r>
+              <a:rPr sz="1600">
+                <a:solidFill>
+                  <a:srgbClr val="1C1712"/>
+                </a:solidFill>
+              </a:rPr>
+              <a:t>Secondary, versus walk-away ceiling: 22.2% (¥36,000.00 total)</a:t>
+            </a:r>
+          </a:p>
+        </p:txBody>
+      </p:sp>
+    </p:spTree>
+  </p:cSld>
+  <p:clrMapOvr>
+    <a:masterClrMapping/>
+  </p:clrMapOvr>
+</p:sld>
+</file>
+
+<file path=ppt/slides/slide8.xml><?xml version="1.0" encoding="utf-8"?>
+<p:sld xmlns:a="http://schemas.openxmlformats.org/drawingml/2006/main" xmlns:p="http://schemas.openxmlformats.org/presentationml/2006/main" xmlns:r="http://schemas.openxmlformats.org/officeDocument/2006/relationships">
+  <p:cSld>
+    <p:spTree>
+      <p:nvGrpSpPr>
+        <p:cNvPr id="1" name=""/>
+        <p:cNvGrpSpPr/>
+        <p:nvPr/>
+      </p:nvGrpSpPr>
+      <p:grpSpPr/>
+      <p:sp>
+        <p:nvSpPr>
+          <p:cNvPr id="2" name="Rectangle 1"/>
           <p:cNvSpPr/>
           <p:nvPr/>
         </p:nvSpPr>
         <p:spPr>
           <a:xfrm>
-            <a:off x="365760" y="320040"/>
-            <a:ext cx="228600" cy="228600"/>
+            <a:off x="0" y="0"/>
+            <a:ext cx="12192000" cy="960120"/>
           </a:xfrm>
-          <a:prstGeom prst="ellipse">
+          <a:prstGeom prst="rect">
             <a:avLst/>
           </a:prstGeom>
           <a:solidFill>
-            <a:srgbClr val="2C6FB5"/>
+            <a:srgbClr val="1E3A4C"/>
           </a:solidFill>
           <a:ln>
             <a:noFill/>
@@ -3893,14 +4394,14 @@
       </p:sp>
       <p:sp>
         <p:nvSpPr>
-          <p:cNvPr id="4" name="TextBox 3"/>
+          <p:cNvPr id="3" name="TextBox 2"/>
           <p:cNvSpPr txBox="1"/>
           <p:nvPr/>
         </p:nvSpPr>
         <p:spPr>
           <a:xfrm>
-            <a:off x="731520" y="201168"/>
-            <a:ext cx="11094415" cy="731520"/>
+            <a:off x="411480" y="201168"/>
+            <a:ext cx="11369040" cy="640080"/>
           </a:xfrm>
           <a:prstGeom prst="rect">
             <a:avLst/>
@@ -3908,32 +4409,32 @@
           <a:noFill/>
         </p:spPr>
         <p:txBody>
-          <a:bodyPr wrap="none" tIns="0" bIns="0">
+          <a:bodyPr wrap="none">
             <a:spAutoFit/>
           </a:bodyPr>
           <a:lstStyle/>
           <a:p>
             <a:r>
-              <a:rPr sz="3000" b="1">
-                <a:solidFill>
-                  <a:srgbClr val="FFFFFF"/>
+              <a:rPr sz="2800" b="1">
+                <a:solidFill>
+                  <a:srgbClr val="FBF7F0"/>
                 </a:solidFill>
               </a:rPr>
-              <a:t>Why not a chatbot — measured, not asserted</a:t>
-            </a:r>
-          </a:p>
-        </p:txBody>
-      </p:sp>
-      <p:sp>
-        <p:nvSpPr>
-          <p:cNvPr id="5" name="TextBox 4"/>
+              <a:t>8. Limits and how to run</a:t>
+            </a:r>
+          </a:p>
+        </p:txBody>
+      </p:sp>
+      <p:sp>
+        <p:nvSpPr>
+          <p:cNvPr id="4" name="TextBox 3"/>
           <p:cNvSpPr txBox="1"/>
           <p:nvPr/>
         </p:nvSpPr>
         <p:spPr>
           <a:xfrm>
-            <a:off x="548640" y="1325880"/>
-            <a:ext cx="11094415" cy="5303520"/>
+            <a:off x="457200" y="1234440"/>
+            <a:ext cx="11277600" cy="5394960"/>
           </a:xfrm>
           <a:prstGeom prst="rect">
             <a:avLst/>
@@ -3941,1548 +4442,68 @@
           <a:noFill/>
         </p:spPr>
         <p:txBody>
-          <a:bodyPr wrap="square" tIns="0" lIns="0" rIns="0"/>
+          <a:bodyPr wrap="square">
+            <a:spAutoFit/>
+          </a:bodyPr>
           <a:lstStyle/>
           <a:p>
             <a:pPr>
-              <a:spcBef>
-                <a:spcPts val="0"/>
-              </a:spcBef>
               <a:spcAft>
-                <a:spcPts val="800"/>
+                <a:spcPts val="1000"/>
               </a:spcAft>
             </a:pPr>
             <a:r>
-              <a:rPr sz="1400">
-                <a:solidFill>
-                  <a:srgbClr val="141E36"/>
+              <a:rPr sz="1600">
+                <a:solidFill>
+                  <a:srgbClr val="1C1712"/>
                 </a:solidFill>
               </a:rPr>
-              <a:t>•  We ran our own real-model benchmark on the AMD endpoint: 100 matches, 348 real inference calls, $0.108.</a:t>
+              <a:t>cp .env.example .env &amp;&amp; docker compose up --build, then open http://localhost:8000.</a:t>
             </a:r>
           </a:p>
           <a:p>
             <a:pPr>
-              <a:spcBef>
-                <a:spcPts val="0"/>
-              </a:spcBef>
               <a:spcAft>
-                <a:spcPts val="800"/>
+                <a:spcPts val="1000"/>
               </a:spcAft>
             </a:pPr>
             <a:r>
-              <a:rPr sz="1400">
-                <a:solidFill>
-                  <a:srgbClr val="141E36"/>
+              <a:rPr sz="1600">
+                <a:solidFill>
+                  <a:srgbClr val="1C1712"/>
                 </a:solidFill>
               </a:rPr>
-              <a:t>•  Real model budget violations: 0/94 (exact 95% upper bound 3.1%) — the simulator's violation figures (12–44% historically; 20–40% in the current 100-match artifact) were NOT reproduced.</a:t>
+              <a:t>Placeholder keys are ignored. /health reports offline_demo and the solver backend.</a:t>
             </a:r>
           </a:p>
           <a:p>
             <a:pPr>
-              <a:spcBef>
-                <a:spcPts val="0"/>
-              </a:spcBef>
               <a:spcAft>
-                <a:spcPts val="800"/>
+                <a:spcPts val="1000"/>
               </a:spcAft>
             </a:pPr>
             <a:r>
-              <a:rPr sz="1400">
-                <a:solidFill>
-                  <a:srgbClr val="141E36"/>
+              <a:rPr sz="1600">
+                <a:solidFill>
+                  <a:srgbClr val="1C1712"/>
                 </a:solidFill>
               </a:rPr>
-              <a:t>•  The real model's actual weakness is BREAKDOWN, not overspending: 61.1% deal-closure vs a Bluffing Hardliner (our solver in the synthetic arena closes 20/20 — but those archetypes carry reserves far below the ceiling, so that gap is scenario structure, NOT solver superiority).</a:t>
+              <a:t>No factory deal. No shipped MI300X timing. MIT. Public repo.</a:t>
             </a:r>
           </a:p>
           <a:p>
             <a:pPr>
-              <a:spcBef>
-                <a:spcPts val="0"/>
-              </a:spcBef>
               <a:spcAft>
-                <a:spcPts val="800"/>
+                <a:spcPts val="1000"/>
               </a:spcAft>
             </a:pPr>
             <a:r>
-              <a:rPr sz="1400">
-                <a:solidFill>
-                  <a:srgbClr val="141E36"/>
+              <a:rPr sz="1600">
+                <a:solidFill>
+                  <a:srgbClr val="1C1712"/>
                 </a:solidFill>
               </a:rPr>
-              <a:t>•  Academic context: NegotiationArena (ICLR 2024), AgenticPay (arXiv:2602.06008), Cattle Trade (arXiv:2605.14537).</a:t>
-            </a:r>
-          </a:p>
-        </p:txBody>
-      </p:sp>
-    </p:spTree>
-  </p:cSld>
-  <p:clrMapOvr>
-    <a:masterClrMapping/>
-  </p:clrMapOvr>
-</p:sld>
-</file>
-
-<file path=ppt/slides/slide4.xml><?xml version="1.0" encoding="utf-8"?>
-<p:sld xmlns:a="http://schemas.openxmlformats.org/drawingml/2006/main" xmlns:p="http://schemas.openxmlformats.org/presentationml/2006/main" xmlns:r="http://schemas.openxmlformats.org/officeDocument/2006/relationships">
-  <p:cSld>
-    <p:spTree>
-      <p:nvGrpSpPr>
-        <p:cNvPr id="1" name=""/>
-        <p:cNvGrpSpPr/>
-        <p:nvPr/>
-      </p:nvGrpSpPr>
-      <p:grpSpPr/>
-      <p:sp>
-        <p:nvSpPr>
-          <p:cNvPr id="2" name="Rectangle 1"/>
-          <p:cNvSpPr/>
-          <p:nvPr/>
-        </p:nvSpPr>
-        <p:spPr>
-          <a:xfrm>
-            <a:off x="0" y="0"/>
-            <a:ext cx="12191695" cy="1005840"/>
-          </a:xfrm>
-          <a:prstGeom prst="rect">
-            <a:avLst/>
-          </a:prstGeom>
-          <a:solidFill>
-            <a:srgbClr val="0B1020"/>
-          </a:solidFill>
-          <a:ln>
-            <a:noFill/>
-          </a:ln>
-        </p:spPr>
-        <p:style>
-          <a:lnRef idx="1">
-            <a:schemeClr val="accent1"/>
-          </a:lnRef>
-          <a:fillRef idx="3">
-            <a:schemeClr val="accent1"/>
-          </a:fillRef>
-          <a:effectRef idx="2">
-            <a:schemeClr val="accent1"/>
-          </a:effectRef>
-          <a:fontRef idx="minor">
-            <a:schemeClr val="lt1"/>
-          </a:fontRef>
-        </p:style>
-        <p:txBody>
-          <a:bodyPr rtlCol="0" anchor="ctr"/>
-          <a:lstStyle/>
-          <a:p>
-            <a:pPr algn="ctr"/>
-          </a:p>
-        </p:txBody>
-      </p:sp>
-      <p:sp>
-        <p:nvSpPr>
-          <p:cNvPr id="3" name="Oval 2"/>
-          <p:cNvSpPr/>
-          <p:nvPr/>
-        </p:nvSpPr>
-        <p:spPr>
-          <a:xfrm>
-            <a:off x="365760" y="320040"/>
-            <a:ext cx="228600" cy="228600"/>
-          </a:xfrm>
-          <a:prstGeom prst="ellipse">
-            <a:avLst/>
-          </a:prstGeom>
-          <a:solidFill>
-            <a:srgbClr val="2C6FB5"/>
-          </a:solidFill>
-          <a:ln>
-            <a:noFill/>
-          </a:ln>
-        </p:spPr>
-        <p:style>
-          <a:lnRef idx="1">
-            <a:schemeClr val="accent1"/>
-          </a:lnRef>
-          <a:fillRef idx="3">
-            <a:schemeClr val="accent1"/>
-          </a:fillRef>
-          <a:effectRef idx="2">
-            <a:schemeClr val="accent1"/>
-          </a:effectRef>
-          <a:fontRef idx="minor">
-            <a:schemeClr val="lt1"/>
-          </a:fontRef>
-        </p:style>
-        <p:txBody>
-          <a:bodyPr rtlCol="0" anchor="ctr"/>
-          <a:lstStyle/>
-          <a:p>
-            <a:pPr algn="ctr"/>
-          </a:p>
-        </p:txBody>
-      </p:sp>
-      <p:sp>
-        <p:nvSpPr>
-          <p:cNvPr id="4" name="TextBox 3"/>
-          <p:cNvSpPr txBox="1"/>
-          <p:nvPr/>
-        </p:nvSpPr>
-        <p:spPr>
-          <a:xfrm>
-            <a:off x="731520" y="201168"/>
-            <a:ext cx="11094415" cy="731520"/>
-          </a:xfrm>
-          <a:prstGeom prst="rect">
-            <a:avLst/>
-          </a:prstGeom>
-          <a:noFill/>
-        </p:spPr>
-        <p:txBody>
-          <a:bodyPr wrap="none" tIns="0" bIns="0">
-            <a:spAutoFit/>
-          </a:bodyPr>
-          <a:lstStyle/>
-          <a:p>
-            <a:r>
-              <a:rPr sz="3000" b="1">
-                <a:solidFill>
-                  <a:srgbClr val="FFFFFF"/>
-                </a:solidFill>
-              </a:rPr>
-              <a:t>Architecture: why decouple</a:t>
-            </a:r>
-          </a:p>
-        </p:txBody>
-      </p:sp>
-      <p:sp>
-        <p:nvSpPr>
-          <p:cNvPr id="5" name="TextBox 4"/>
-          <p:cNvSpPr txBox="1"/>
-          <p:nvPr/>
-        </p:nvSpPr>
-        <p:spPr>
-          <a:xfrm>
-            <a:off x="548640" y="1325880"/>
-            <a:ext cx="11094415" cy="5303520"/>
-          </a:xfrm>
-          <a:prstGeom prst="rect">
-            <a:avLst/>
-          </a:prstGeom>
-          <a:noFill/>
-        </p:spPr>
-        <p:txBody>
-          <a:bodyPr wrap="square" tIns="0" lIns="0" rIns="0"/>
-          <a:lstStyle/>
-          <a:p>
-            <a:pPr>
-              <a:spcBef>
-                <a:spcPts val="0"/>
-              </a:spcBef>
-              <a:spcAft>
-                <a:spcPts val="800"/>
-              </a:spcAft>
-            </a:pPr>
-            <a:r>
-              <a:rPr sz="1400">
-                <a:solidFill>
-                  <a:srgbClr val="141E36"/>
-                </a:solidFill>
-              </a:rPr>
-              <a:t>•  Numerical decision core (NumPy tensor solver, no LLM in the decision path).</a:t>
-            </a:r>
-          </a:p>
-          <a:p>
-            <a:pPr>
-              <a:spcBef>
-                <a:spcPts val="0"/>
-              </a:spcBef>
-              <a:spcAft>
-                <a:spcPts val="800"/>
-              </a:spcAft>
-            </a:pPr>
-            <a:r>
-              <a:rPr sz="1400">
-                <a:solidFill>
-                  <a:srgbClr val="141E36"/>
-                </a:solidFill>
-              </a:rPr>
-              <a:t>•  Dual-tier defense: Tier-1 AST invariant guardrail on the strategy object + Tier-2 deterministic templates for language.</a:t>
-            </a:r>
-          </a:p>
-          <a:p>
-            <a:pPr>
-              <a:spcBef>
-                <a:spcPts val="0"/>
-              </a:spcBef>
-              <a:spcAft>
-                <a:spcPts val="800"/>
-              </a:spcAft>
-            </a:pPr>
-            <a:r>
-              <a:rPr sz="1400">
-                <a:solidFill>
-                  <a:srgbClr val="141E36"/>
-                </a:solidFill>
-              </a:rPr>
-              <a:t>•  Pareto Logrolling: swap non-price terms (deposit for lead time, volume for price) when unit price deadlocks.</a:t>
-            </a:r>
-          </a:p>
-          <a:p>
-            <a:pPr>
-              <a:spcBef>
-                <a:spcPts val="0"/>
-              </a:spcBef>
-              <a:spcAft>
-                <a:spcPts val="800"/>
-              </a:spcAft>
-            </a:pPr>
-            <a:r>
-              <a:rPr sz="1400">
-                <a:solidFill>
-                  <a:srgbClr val="141E36"/>
-                </a:solidFill>
-              </a:rPr>
-              <a:t>•  Deterministic degradation: Stage-1 regex + on-device ONNX runs offline; Stage-2 LLM is optional.</a:t>
-            </a:r>
-          </a:p>
-          <a:p>
-            <a:pPr>
-              <a:spcBef>
-                <a:spcPts val="0"/>
-              </a:spcBef>
-              <a:spcAft>
-                <a:spcPts val="800"/>
-              </a:spcAft>
-            </a:pPr>
-            <a:r>
-              <a:rPr sz="1400">
-                <a:solidFill>
-                  <a:srgbClr val="141E36"/>
-                </a:solidFill>
-              </a:rPr>
-              <a:t>•  Latency, honestly: Stage-1 mean ~0.13 ms (p99 ~0.49 ms); full HTTP round ~3.3 s (solver-bound), not '&lt;3 ms end-to-end'.</a:t>
-            </a:r>
-          </a:p>
-        </p:txBody>
-      </p:sp>
-    </p:spTree>
-  </p:cSld>
-  <p:clrMapOvr>
-    <a:masterClrMapping/>
-  </p:clrMapOvr>
-</p:sld>
-</file>
-
-<file path=ppt/slides/slide5.xml><?xml version="1.0" encoding="utf-8"?>
-<p:sld xmlns:a="http://schemas.openxmlformats.org/drawingml/2006/main" xmlns:p="http://schemas.openxmlformats.org/presentationml/2006/main" xmlns:r="http://schemas.openxmlformats.org/officeDocument/2006/relationships">
-  <p:cSld>
-    <p:spTree>
-      <p:nvGrpSpPr>
-        <p:cNvPr id="1" name=""/>
-        <p:cNvGrpSpPr/>
-        <p:nvPr/>
-      </p:nvGrpSpPr>
-      <p:grpSpPr/>
-      <p:sp>
-        <p:nvSpPr>
-          <p:cNvPr id="2" name="Rectangle 1"/>
-          <p:cNvSpPr/>
-          <p:nvPr/>
-        </p:nvSpPr>
-        <p:spPr>
-          <a:xfrm>
-            <a:off x="0" y="0"/>
-            <a:ext cx="12191695" cy="1005840"/>
-          </a:xfrm>
-          <a:prstGeom prst="rect">
-            <a:avLst/>
-          </a:prstGeom>
-          <a:solidFill>
-            <a:srgbClr val="0B1020"/>
-          </a:solidFill>
-          <a:ln>
-            <a:noFill/>
-          </a:ln>
-        </p:spPr>
-        <p:style>
-          <a:lnRef idx="1">
-            <a:schemeClr val="accent1"/>
-          </a:lnRef>
-          <a:fillRef idx="3">
-            <a:schemeClr val="accent1"/>
-          </a:fillRef>
-          <a:effectRef idx="2">
-            <a:schemeClr val="accent1"/>
-          </a:effectRef>
-          <a:fontRef idx="minor">
-            <a:schemeClr val="lt1"/>
-          </a:fontRef>
-        </p:style>
-        <p:txBody>
-          <a:bodyPr rtlCol="0" anchor="ctr"/>
-          <a:lstStyle/>
-          <a:p>
-            <a:pPr algn="ctr"/>
-          </a:p>
-        </p:txBody>
-      </p:sp>
-      <p:sp>
-        <p:nvSpPr>
-          <p:cNvPr id="3" name="Oval 2"/>
-          <p:cNvSpPr/>
-          <p:nvPr/>
-        </p:nvSpPr>
-        <p:spPr>
-          <a:xfrm>
-            <a:off x="365760" y="320040"/>
-            <a:ext cx="228600" cy="228600"/>
-          </a:xfrm>
-          <a:prstGeom prst="ellipse">
-            <a:avLst/>
-          </a:prstGeom>
-          <a:solidFill>
-            <a:srgbClr val="2C6FB5"/>
-          </a:solidFill>
-          <a:ln>
-            <a:noFill/>
-          </a:ln>
-        </p:spPr>
-        <p:style>
-          <a:lnRef idx="1">
-            <a:schemeClr val="accent1"/>
-          </a:lnRef>
-          <a:fillRef idx="3">
-            <a:schemeClr val="accent1"/>
-          </a:fillRef>
-          <a:effectRef idx="2">
-            <a:schemeClr val="accent1"/>
-          </a:effectRef>
-          <a:fontRef idx="minor">
-            <a:schemeClr val="lt1"/>
-          </a:fontRef>
-        </p:style>
-        <p:txBody>
-          <a:bodyPr rtlCol="0" anchor="ctr"/>
-          <a:lstStyle/>
-          <a:p>
-            <a:pPr algn="ctr"/>
-          </a:p>
-        </p:txBody>
-      </p:sp>
-      <p:sp>
-        <p:nvSpPr>
-          <p:cNvPr id="4" name="TextBox 3"/>
-          <p:cNvSpPr txBox="1"/>
-          <p:nvPr/>
-        </p:nvSpPr>
-        <p:spPr>
-          <a:xfrm>
-            <a:off x="731520" y="201168"/>
-            <a:ext cx="11094415" cy="731520"/>
-          </a:xfrm>
-          <a:prstGeom prst="rect">
-            <a:avLst/>
-          </a:prstGeom>
-          <a:noFill/>
-        </p:spPr>
-        <p:txBody>
-          <a:bodyPr wrap="none" tIns="0" bIns="0">
-            <a:spAutoFit/>
-          </a:bodyPr>
-          <a:lstStyle/>
-          <a:p>
-            <a:r>
-              <a:rPr sz="3000" b="1">
-                <a:solidFill>
-                  <a:srgbClr val="FFFFFF"/>
-                </a:solidFill>
-              </a:rPr>
-              <a:t>Demo: three verifiable moments</a:t>
-            </a:r>
-          </a:p>
-        </p:txBody>
-      </p:sp>
-      <p:sp>
-        <p:nvSpPr>
-          <p:cNvPr id="5" name="TextBox 4"/>
-          <p:cNvSpPr txBox="1"/>
-          <p:nvPr/>
-        </p:nvSpPr>
-        <p:spPr>
-          <a:xfrm>
-            <a:off x="548640" y="1325880"/>
-            <a:ext cx="11094415" cy="5303520"/>
-          </a:xfrm>
-          <a:prstGeom prst="rect">
-            <a:avLst/>
-          </a:prstGeom>
-          <a:noFill/>
-        </p:spPr>
-        <p:txBody>
-          <a:bodyPr wrap="square" tIns="0" lIns="0" rIns="0"/>
-          <a:lstStyle/>
-          <a:p>
-            <a:pPr>
-              <a:spcBef>
-                <a:spcPts val="0"/>
-              </a:spcBef>
-              <a:spcAft>
-                <a:spcPts val="800"/>
-              </a:spcAft>
-            </a:pPr>
-            <a:r>
-              <a:rPr sz="1400">
-                <a:solidFill>
-                  <a:srgbClr val="141E36"/>
-                </a:solidFill>
-              </a:rPr>
-              <a:t>•  1. Belief convergence: Bayesian posterior reserve tracking across rounds (results/belief_update.png).</a:t>
-            </a:r>
-          </a:p>
-          <a:p>
-            <a:pPr>
-              <a:spcBef>
-                <a:spcPts val="0"/>
-              </a:spcBef>
-              <a:spcAft>
-                <a:spcPts val="800"/>
-              </a:spcAft>
-            </a:pPr>
-            <a:r>
-              <a:rPr sz="1400">
-                <a:solidFill>
-                  <a:srgbClr val="141E36"/>
-                </a:solidFill>
-              </a:rPr>
-              <a:t>•  2. AST guardrail rejects a &gt;60% deposit demand — the object is blocked before it can be rendered.</a:t>
-            </a:r>
-          </a:p>
-          <a:p>
-            <a:pPr>
-              <a:spcBef>
-                <a:spcPts val="0"/>
-              </a:spcBef>
-              <a:spcAft>
-                <a:spcPts val="800"/>
-              </a:spcAft>
-            </a:pPr>
-            <a:r>
-              <a:rPr sz="1400">
-                <a:solidFill>
-                  <a:srgbClr val="141E36"/>
-                </a:solidFill>
-              </a:rPr>
-              <a:t>•  3. Multi-supplier reverse auction: 4 dynamic adversary agents quote round-by-round; BATNA ceilings tighten.</a:t>
-            </a:r>
-          </a:p>
-          <a:p>
-            <a:pPr>
-              <a:spcBef>
-                <a:spcPts val="0"/>
-              </a:spcBef>
-              <a:spcAft>
-                <a:spcPts val="800"/>
-              </a:spcAft>
-            </a:pPr>
-            <a:r>
-              <a:rPr sz="1400">
-                <a:solidFill>
-                  <a:srgbClr val="141E36"/>
-                </a:solidFill>
-              </a:rPr>
-              <a:t>•  All reproducible: verify_all.py (6 pillars), verify_live.py (7 E2E checks), 327 tests + 68 subtests green.</a:t>
-            </a:r>
-          </a:p>
-        </p:txBody>
-      </p:sp>
-    </p:spTree>
-  </p:cSld>
-  <p:clrMapOvr>
-    <a:masterClrMapping/>
-  </p:clrMapOvr>
-</p:sld>
-</file>
-
-<file path=ppt/slides/slide6.xml><?xml version="1.0" encoding="utf-8"?>
-<p:sld xmlns:a="http://schemas.openxmlformats.org/drawingml/2006/main" xmlns:p="http://schemas.openxmlformats.org/presentationml/2006/main" xmlns:r="http://schemas.openxmlformats.org/officeDocument/2006/relationships">
-  <p:cSld>
-    <p:spTree>
-      <p:nvGrpSpPr>
-        <p:cNvPr id="1" name=""/>
-        <p:cNvGrpSpPr/>
-        <p:nvPr/>
-      </p:nvGrpSpPr>
-      <p:grpSpPr/>
-      <p:sp>
-        <p:nvSpPr>
-          <p:cNvPr id="2" name="Rectangle 1"/>
-          <p:cNvSpPr/>
-          <p:nvPr/>
-        </p:nvSpPr>
-        <p:spPr>
-          <a:xfrm>
-            <a:off x="0" y="0"/>
-            <a:ext cx="12191695" cy="1005840"/>
-          </a:xfrm>
-          <a:prstGeom prst="rect">
-            <a:avLst/>
-          </a:prstGeom>
-          <a:solidFill>
-            <a:srgbClr val="0B1020"/>
-          </a:solidFill>
-          <a:ln>
-            <a:noFill/>
-          </a:ln>
-        </p:spPr>
-        <p:style>
-          <a:lnRef idx="1">
-            <a:schemeClr val="accent1"/>
-          </a:lnRef>
-          <a:fillRef idx="3">
-            <a:schemeClr val="accent1"/>
-          </a:fillRef>
-          <a:effectRef idx="2">
-            <a:schemeClr val="accent1"/>
-          </a:effectRef>
-          <a:fontRef idx="minor">
-            <a:schemeClr val="lt1"/>
-          </a:fontRef>
-        </p:style>
-        <p:txBody>
-          <a:bodyPr rtlCol="0" anchor="ctr"/>
-          <a:lstStyle/>
-          <a:p>
-            <a:pPr algn="ctr"/>
-          </a:p>
-        </p:txBody>
-      </p:sp>
-      <p:sp>
-        <p:nvSpPr>
-          <p:cNvPr id="3" name="Oval 2"/>
-          <p:cNvSpPr/>
-          <p:nvPr/>
-        </p:nvSpPr>
-        <p:spPr>
-          <a:xfrm>
-            <a:off x="365760" y="320040"/>
-            <a:ext cx="228600" cy="228600"/>
-          </a:xfrm>
-          <a:prstGeom prst="ellipse">
-            <a:avLst/>
-          </a:prstGeom>
-          <a:solidFill>
-            <a:srgbClr val="2C6FB5"/>
-          </a:solidFill>
-          <a:ln>
-            <a:noFill/>
-          </a:ln>
-        </p:spPr>
-        <p:style>
-          <a:lnRef idx="1">
-            <a:schemeClr val="accent1"/>
-          </a:lnRef>
-          <a:fillRef idx="3">
-            <a:schemeClr val="accent1"/>
-          </a:fillRef>
-          <a:effectRef idx="2">
-            <a:schemeClr val="accent1"/>
-          </a:effectRef>
-          <a:fontRef idx="minor">
-            <a:schemeClr val="lt1"/>
-          </a:fontRef>
-        </p:style>
-        <p:txBody>
-          <a:bodyPr rtlCol="0" anchor="ctr"/>
-          <a:lstStyle/>
-          <a:p>
-            <a:pPr algn="ctr"/>
-          </a:p>
-        </p:txBody>
-      </p:sp>
-      <p:sp>
-        <p:nvSpPr>
-          <p:cNvPr id="4" name="TextBox 3"/>
-          <p:cNvSpPr txBox="1"/>
-          <p:nvPr/>
-        </p:nvSpPr>
-        <p:spPr>
-          <a:xfrm>
-            <a:off x="731520" y="201168"/>
-            <a:ext cx="11094415" cy="731520"/>
-          </a:xfrm>
-          <a:prstGeom prst="rect">
-            <a:avLst/>
-          </a:prstGeom>
-          <a:noFill/>
-        </p:spPr>
-        <p:txBody>
-          <a:bodyPr wrap="none" tIns="0" bIns="0">
-            <a:spAutoFit/>
-          </a:bodyPr>
-          <a:lstStyle/>
-          <a:p>
-            <a:r>
-              <a:rPr sz="3000" b="1">
-                <a:solidFill>
-                  <a:srgbClr val="FFFFFF"/>
-                </a:solidFill>
-              </a:rPr>
-              <a:t>User story: a single operator</a:t>
-            </a:r>
-          </a:p>
-        </p:txBody>
-      </p:sp>
-      <p:sp>
-        <p:nvSpPr>
-          <p:cNvPr id="5" name="TextBox 4"/>
-          <p:cNvSpPr txBox="1"/>
-          <p:nvPr/>
-        </p:nvSpPr>
-        <p:spPr>
-          <a:xfrm>
-            <a:off x="548640" y="1325880"/>
-            <a:ext cx="11094415" cy="5303520"/>
-          </a:xfrm>
-          <a:prstGeom prst="rect">
-            <a:avLst/>
-          </a:prstGeom>
-          <a:noFill/>
-        </p:spPr>
-        <p:txBody>
-          <a:bodyPr wrap="square" tIns="0" lIns="0" rIns="0"/>
-          <a:lstStyle/>
-          <a:p>
-            <a:pPr>
-              <a:spcBef>
-                <a:spcPts val="0"/>
-              </a:spcBef>
-              <a:spcAft>
-                <a:spcPts val="800"/>
-              </a:spcAft>
-            </a:pPr>
-            <a:r>
-              <a:rPr sz="1400">
-                <a:solidFill>
-                  <a:srgbClr val="141E36"/>
-                </a:solidFill>
-              </a:rPr>
-              <a:t>•  An Amazon outdoor seller buys ~50,000 umbrellas/yr from China.</a:t>
-            </a:r>
-          </a:p>
-          <a:p>
-            <a:pPr>
-              <a:spcBef>
-                <a:spcPts val="0"/>
-              </a:spcBef>
-              <a:spcAft>
-                <a:spcPts val="800"/>
-              </a:spcAft>
-            </a:pPr>
-            <a:r>
-              <a:rPr sz="1400">
-                <a:solidFill>
-                  <a:srgbClr val="141E36"/>
-                </a:solidFill>
-              </a:rPr>
-              <a:t>•  Status quo: Google Translate on 1688 invites a foreigner markup and hidden mould fees; agents charge 7% and take kickbacks.</a:t>
-            </a:r>
-          </a:p>
-          <a:p>
-            <a:pPr>
-              <a:spcBef>
-                <a:spcPts val="0"/>
-              </a:spcBef>
-              <a:spcAft>
-                <a:spcPts val="800"/>
-              </a:spcAft>
-            </a:pPr>
-            <a:r>
-              <a:rPr sz="1400">
-                <a:solidFill>
-                  <a:srgbClr val="141E36"/>
-                </a:solidFill>
-              </a:rPr>
-              <a:t>•  With TradeFlow: the engine proposes an opening price and concession curve; the operator approves via a mobile card.</a:t>
-            </a:r>
-          </a:p>
-          <a:p>
-            <a:pPr>
-              <a:spcBef>
-                <a:spcPts val="0"/>
-              </a:spcBef>
-              <a:spcAft>
-                <a:spcPts val="800"/>
-              </a:spcAft>
-            </a:pPr>
-            <a:r>
-              <a:rPr sz="1400">
-                <a:solidFill>
-                  <a:srgbClr val="141E36"/>
-                </a:solidFill>
-              </a:rPr>
-              <a:t>•  Savings claim: 7% commission + foreigner markup + mould fees — each component documented separately, not one fabricated figure.</a:t>
-            </a:r>
-          </a:p>
-        </p:txBody>
-      </p:sp>
-    </p:spTree>
-  </p:cSld>
-  <p:clrMapOvr>
-    <a:masterClrMapping/>
-  </p:clrMapOvr>
-</p:sld>
-</file>
-
-<file path=ppt/slides/slide7.xml><?xml version="1.0" encoding="utf-8"?>
-<p:sld xmlns:a="http://schemas.openxmlformats.org/drawingml/2006/main" xmlns:p="http://schemas.openxmlformats.org/presentationml/2006/main" xmlns:r="http://schemas.openxmlformats.org/officeDocument/2006/relationships">
-  <p:cSld>
-    <p:spTree>
-      <p:nvGrpSpPr>
-        <p:cNvPr id="1" name=""/>
-        <p:cNvGrpSpPr/>
-        <p:nvPr/>
-      </p:nvGrpSpPr>
-      <p:grpSpPr/>
-      <p:sp>
-        <p:nvSpPr>
-          <p:cNvPr id="2" name="Rectangle 1"/>
-          <p:cNvSpPr/>
-          <p:nvPr/>
-        </p:nvSpPr>
-        <p:spPr>
-          <a:xfrm>
-            <a:off x="0" y="0"/>
-            <a:ext cx="12191695" cy="1005840"/>
-          </a:xfrm>
-          <a:prstGeom prst="rect">
-            <a:avLst/>
-          </a:prstGeom>
-          <a:solidFill>
-            <a:srgbClr val="0B1020"/>
-          </a:solidFill>
-          <a:ln>
-            <a:noFill/>
-          </a:ln>
-        </p:spPr>
-        <p:style>
-          <a:lnRef idx="1">
-            <a:schemeClr val="accent1"/>
-          </a:lnRef>
-          <a:fillRef idx="3">
-            <a:schemeClr val="accent1"/>
-          </a:fillRef>
-          <a:effectRef idx="2">
-            <a:schemeClr val="accent1"/>
-          </a:effectRef>
-          <a:fontRef idx="minor">
-            <a:schemeClr val="lt1"/>
-          </a:fontRef>
-        </p:style>
-        <p:txBody>
-          <a:bodyPr rtlCol="0" anchor="ctr"/>
-          <a:lstStyle/>
-          <a:p>
-            <a:pPr algn="ctr"/>
-          </a:p>
-        </p:txBody>
-      </p:sp>
-      <p:sp>
-        <p:nvSpPr>
-          <p:cNvPr id="3" name="Oval 2"/>
-          <p:cNvSpPr/>
-          <p:nvPr/>
-        </p:nvSpPr>
-        <p:spPr>
-          <a:xfrm>
-            <a:off x="365760" y="320040"/>
-            <a:ext cx="228600" cy="228600"/>
-          </a:xfrm>
-          <a:prstGeom prst="ellipse">
-            <a:avLst/>
-          </a:prstGeom>
-          <a:solidFill>
-            <a:srgbClr val="2C6FB5"/>
-          </a:solidFill>
-          <a:ln>
-            <a:noFill/>
-          </a:ln>
-        </p:spPr>
-        <p:style>
-          <a:lnRef idx="1">
-            <a:schemeClr val="accent1"/>
-          </a:lnRef>
-          <a:fillRef idx="3">
-            <a:schemeClr val="accent1"/>
-          </a:fillRef>
-          <a:effectRef idx="2">
-            <a:schemeClr val="accent1"/>
-          </a:effectRef>
-          <a:fontRef idx="minor">
-            <a:schemeClr val="lt1"/>
-          </a:fontRef>
-        </p:style>
-        <p:txBody>
-          <a:bodyPr rtlCol="0" anchor="ctr"/>
-          <a:lstStyle/>
-          <a:p>
-            <a:pPr algn="ctr"/>
-          </a:p>
-        </p:txBody>
-      </p:sp>
-      <p:sp>
-        <p:nvSpPr>
-          <p:cNvPr id="4" name="TextBox 3"/>
-          <p:cNvSpPr txBox="1"/>
-          <p:nvPr/>
-        </p:nvSpPr>
-        <p:spPr>
-          <a:xfrm>
-            <a:off x="731520" y="201168"/>
-            <a:ext cx="11094415" cy="731520"/>
-          </a:xfrm>
-          <a:prstGeom prst="rect">
-            <a:avLst/>
-          </a:prstGeom>
-          <a:noFill/>
-        </p:spPr>
-        <p:txBody>
-          <a:bodyPr wrap="none" tIns="0" bIns="0">
-            <a:spAutoFit/>
-          </a:bodyPr>
-          <a:lstStyle/>
-          <a:p>
-            <a:r>
-              <a:rPr sz="3000" b="1">
-                <a:solidFill>
-                  <a:srgbClr val="FFFFFF"/>
-                </a:solidFill>
-              </a:rPr>
-              <a:t>AMD integration — honest version</a:t>
-            </a:r>
-          </a:p>
-        </p:txBody>
-      </p:sp>
-      <p:sp>
-        <p:nvSpPr>
-          <p:cNvPr id="5" name="TextBox 4"/>
-          <p:cNvSpPr txBox="1"/>
-          <p:nvPr/>
-        </p:nvSpPr>
-        <p:spPr>
-          <a:xfrm>
-            <a:off x="548640" y="1325880"/>
-            <a:ext cx="11094415" cy="5303520"/>
-          </a:xfrm>
-          <a:prstGeom prst="rect">
-            <a:avLst/>
-          </a:prstGeom>
-          <a:noFill/>
-        </p:spPr>
-        <p:txBody>
-          <a:bodyPr wrap="square" tIns="0" lIns="0" rIns="0"/>
-          <a:lstStyle/>
-          <a:p>
-            <a:pPr>
-              <a:spcBef>
-                <a:spcPts val="0"/>
-              </a:spcBef>
-              <a:spcAft>
-                <a:spcPts val="800"/>
-              </a:spcAft>
-            </a:pPr>
-            <a:r>
-              <a:rPr sz="1400">
-                <a:solidFill>
-                  <a:srgbClr val="141E36"/>
-                </a:solidFill>
-              </a:rPr>
-              <a:t>•  Model layer really runs on AMD: Stage-2 classification and the Evolus Agent both call AMD tokenfactory (Qwen3.8-Flash-Next), verified HTTP 200.</a:t>
-            </a:r>
-          </a:p>
-          <a:p>
-            <a:pPr>
-              <a:spcBef>
-                <a:spcPts val="0"/>
-              </a:spcBef>
-              <a:spcAft>
-                <a:spcPts val="800"/>
-              </a:spcAft>
-            </a:pPr>
-            <a:r>
-              <a:rPr sz="1400">
-                <a:solidFill>
-                  <a:srgbClr val="141E36"/>
-                </a:solidFill>
-              </a:rPr>
-              <a:t>•  Engine is GPU-shaped: 20,000 opponent samples × 480 strategies = 9.6M rollouts/round, memory-bandwidth bound.</a:t>
-            </a:r>
-          </a:p>
-          <a:p>
-            <a:pPr>
-              <a:spcBef>
-                <a:spcPts val="0"/>
-              </a:spcBef>
-              <a:spcAft>
-                <a:spcPts val="800"/>
-              </a:spcAft>
-            </a:pPr>
-            <a:r>
-              <a:rPr sz="1400">
-                <a:solidFill>
-                  <a:srgbClr val="141E36"/>
-                </a:solidFill>
-              </a:rPr>
-              <a:t>•  Multi-supplier demo path: 4 suppliers × 20,000 samples × 20 opens × 6 scheds = 9.6M grid cells/round × 3 rounds = 28.8M parameterised cells (NOT a measured iteration count).</a:t>
-            </a:r>
-          </a:p>
-          <a:p>
-            <a:pPr>
-              <a:spcBef>
-                <a:spcPts val="0"/>
-              </a:spcBef>
-              <a:spcAft>
-                <a:spcPts val="800"/>
-              </a:spcAft>
-            </a:pPr>
-            <a:r>
-              <a:rPr sz="1400">
-                <a:solidFill>
-                  <a:srgbClr val="141E36"/>
-                </a:solidFill>
-              </a:rPr>
-              <a:t>•  Measured here (CPU): ~6.3M rollouts/sec peak at n=50,000 (results/bench.json, regenerated after the decision-core fix).</a:t>
-            </a:r>
-          </a:p>
-          <a:p>
-            <a:pPr>
-              <a:spcBef>
-                <a:spcPts val="0"/>
-              </a:spcBef>
-              <a:spcAft>
-                <a:spcPts val="800"/>
-              </a:spcAft>
-            </a:pPr>
-            <a:r>
-              <a:rPr sz="1400">
-                <a:solidFill>
-                  <a:srgbClr val="141E36"/>
-                </a:solidFill>
-              </a:rPr>
-              <a:t>•  MI300X: no measurement exists — the analytical roofline LOWER BOUND (working set ÷ 5300 GB/s) is a physical bound, not a projection.</a:t>
-            </a:r>
-          </a:p>
-          <a:p>
-            <a:pPr>
-              <a:spcBef>
-                <a:spcPts val="0"/>
-              </a:spcBef>
-              <a:spcAft>
-                <a:spcPts val="800"/>
-              </a:spcAft>
-            </a:pPr>
-            <a:r>
-              <a:rPr sz="1400">
-                <a:solidFill>
-                  <a:srgbClr val="141E36"/>
-                </a:solidFill>
-              </a:rPr>
-              <a:t>•  One-line portability via the _xp() tensor abstraction (NumPy ↔ CuPy/ROCm).</a:t>
-            </a:r>
-          </a:p>
-        </p:txBody>
-      </p:sp>
-    </p:spTree>
-  </p:cSld>
-  <p:clrMapOvr>
-    <a:masterClrMapping/>
-  </p:clrMapOvr>
-</p:sld>
-</file>
-
-<file path=ppt/slides/slide8.xml><?xml version="1.0" encoding="utf-8"?>
-<p:sld xmlns:a="http://schemas.openxmlformats.org/drawingml/2006/main" xmlns:p="http://schemas.openxmlformats.org/presentationml/2006/main" xmlns:r="http://schemas.openxmlformats.org/officeDocument/2006/relationships">
-  <p:cSld>
-    <p:spTree>
-      <p:nvGrpSpPr>
-        <p:cNvPr id="1" name=""/>
-        <p:cNvGrpSpPr/>
-        <p:nvPr/>
-      </p:nvGrpSpPr>
-      <p:grpSpPr/>
-      <p:sp>
-        <p:nvSpPr>
-          <p:cNvPr id="2" name="Rectangle 1"/>
-          <p:cNvSpPr/>
-          <p:nvPr/>
-        </p:nvSpPr>
-        <p:spPr>
-          <a:xfrm>
-            <a:off x="0" y="0"/>
-            <a:ext cx="12191695" cy="1005840"/>
-          </a:xfrm>
-          <a:prstGeom prst="rect">
-            <a:avLst/>
-          </a:prstGeom>
-          <a:solidFill>
-            <a:srgbClr val="0B1020"/>
-          </a:solidFill>
-          <a:ln>
-            <a:noFill/>
-          </a:ln>
-        </p:spPr>
-        <p:style>
-          <a:lnRef idx="1">
-            <a:schemeClr val="accent1"/>
-          </a:lnRef>
-          <a:fillRef idx="3">
-            <a:schemeClr val="accent1"/>
-          </a:fillRef>
-          <a:effectRef idx="2">
-            <a:schemeClr val="accent1"/>
-          </a:effectRef>
-          <a:fontRef idx="minor">
-            <a:schemeClr val="lt1"/>
-          </a:fontRef>
-        </p:style>
-        <p:txBody>
-          <a:bodyPr rtlCol="0" anchor="ctr"/>
-          <a:lstStyle/>
-          <a:p>
-            <a:pPr algn="ctr"/>
-          </a:p>
-        </p:txBody>
-      </p:sp>
-      <p:sp>
-        <p:nvSpPr>
-          <p:cNvPr id="3" name="Oval 2"/>
-          <p:cNvSpPr/>
-          <p:nvPr/>
-        </p:nvSpPr>
-        <p:spPr>
-          <a:xfrm>
-            <a:off x="365760" y="320040"/>
-            <a:ext cx="228600" cy="228600"/>
-          </a:xfrm>
-          <a:prstGeom prst="ellipse">
-            <a:avLst/>
-          </a:prstGeom>
-          <a:solidFill>
-            <a:srgbClr val="2C6FB5"/>
-          </a:solidFill>
-          <a:ln>
-            <a:noFill/>
-          </a:ln>
-        </p:spPr>
-        <p:style>
-          <a:lnRef idx="1">
-            <a:schemeClr val="accent1"/>
-          </a:lnRef>
-          <a:fillRef idx="3">
-            <a:schemeClr val="accent1"/>
-          </a:fillRef>
-          <a:effectRef idx="2">
-            <a:schemeClr val="accent1"/>
-          </a:effectRef>
-          <a:fontRef idx="minor">
-            <a:schemeClr val="lt1"/>
-          </a:fontRef>
-        </p:style>
-        <p:txBody>
-          <a:bodyPr rtlCol="0" anchor="ctr"/>
-          <a:lstStyle/>
-          <a:p>
-            <a:pPr algn="ctr"/>
-          </a:p>
-        </p:txBody>
-      </p:sp>
-      <p:sp>
-        <p:nvSpPr>
-          <p:cNvPr id="4" name="TextBox 3"/>
-          <p:cNvSpPr txBox="1"/>
-          <p:nvPr/>
-        </p:nvSpPr>
-        <p:spPr>
-          <a:xfrm>
-            <a:off x="731520" y="201168"/>
-            <a:ext cx="11094415" cy="731520"/>
-          </a:xfrm>
-          <a:prstGeom prst="rect">
-            <a:avLst/>
-          </a:prstGeom>
-          <a:noFill/>
-        </p:spPr>
-        <p:txBody>
-          <a:bodyPr wrap="none" tIns="0" bIns="0">
-            <a:spAutoFit/>
-          </a:bodyPr>
-          <a:lstStyle/>
-          <a:p>
-            <a:r>
-              <a:rPr sz="3000" b="1">
-                <a:solidFill>
-                  <a:srgbClr val="FFFFFF"/>
-                </a:solidFill>
-              </a:rPr>
-              <a:t>Evolus integration — all real calls</a:t>
-            </a:r>
-          </a:p>
-        </p:txBody>
-      </p:sp>
-      <p:sp>
-        <p:nvSpPr>
-          <p:cNvPr id="5" name="TextBox 4"/>
-          <p:cNvSpPr txBox="1"/>
-          <p:nvPr/>
-        </p:nvSpPr>
-        <p:spPr>
-          <a:xfrm>
-            <a:off x="548640" y="1325880"/>
-            <a:ext cx="11094415" cy="5303520"/>
-          </a:xfrm>
-          <a:prstGeom prst="rect">
-            <a:avLst/>
-          </a:prstGeom>
-          <a:noFill/>
-        </p:spPr>
-        <p:txBody>
-          <a:bodyPr wrap="square" tIns="0" lIns="0" rIns="0"/>
-          <a:lstStyle/>
-          <a:p>
-            <a:pPr>
-              <a:spcBef>
-                <a:spcPts val="0"/>
-              </a:spcBef>
-              <a:spcAft>
-                <a:spcPts val="800"/>
-              </a:spcAft>
-            </a:pPr>
-            <a:r>
-              <a:rPr sz="1400">
-                <a:solidFill>
-                  <a:srgbClr val="141E36"/>
-                </a:solidFill>
-              </a:rPr>
-              <a:t>•  Building blocks actually exercised (real usage stats): email 2.46, doc-structure 2.12, sentiment 3.75 credits.</a:t>
-            </a:r>
-          </a:p>
-          <a:p>
-            <a:pPr>
-              <a:spcBef>
-                <a:spcPts val="0"/>
-              </a:spcBef>
-              <a:spcAft>
-                <a:spcPts val="800"/>
-              </a:spcAft>
-            </a:pPr>
-            <a:r>
-              <a:rPr sz="1400">
-                <a:solidFill>
-                  <a:srgbClr val="141E36"/>
-                </a:solidFill>
-              </a:rPr>
-              <a:t>•  Agent 'Supplier Negotiation Analyst' live-verified via POST /v1/chat/completions (HTTP 200), model bound own/qwen3.8-flash-next.</a:t>
-            </a:r>
-          </a:p>
-          <a:p>
-            <a:pPr>
-              <a:spcBef>
-                <a:spcPts val="0"/>
-              </a:spcBef>
-              <a:spcAft>
-                <a:spcPts val="800"/>
-              </a:spcAft>
-            </a:pPr>
-            <a:r>
-              <a:rPr sz="1400">
-                <a:solidFill>
-                  <a:srgbClr val="141E36"/>
-                </a:solidFill>
-              </a:rPr>
-              <a:t>•  App-driven REST: orchestrator.on_webhook() → engine → real Evolus AI Tool draft (no longer an offline stub).</a:t>
-            </a:r>
-          </a:p>
-          <a:p>
-            <a:pPr>
-              <a:spcBef>
-                <a:spcPts val="0"/>
-              </a:spcBef>
-              <a:spcAft>
-                <a:spcPts val="800"/>
-              </a:spcAft>
-            </a:pPr>
-            <a:r>
-              <a:rPr sz="1400">
-                <a:solidFill>
-                  <a:srgbClr val="141E36"/>
-                </a:solidFill>
-              </a:rPr>
-              <a:t>•  Knowledge library: real UN Comtrade customs data + live FX feed the agent's cost analysis.</a:t>
-            </a:r>
-          </a:p>
-          <a:p>
-            <a:pPr>
-              <a:spcBef>
-                <a:spcPts val="0"/>
-              </a:spcBef>
-              <a:spcAft>
-                <a:spcPts val="800"/>
-              </a:spcAft>
-            </a:pPr>
-            <a:r>
-              <a:rPr sz="1400">
-                <a:solidFill>
-                  <a:srgbClr val="141E36"/>
-                </a:solidFill>
-              </a:rPr>
-              <a:t>•  Remaining gap: the Evolus-side Automation (workflow) has not yet been created in the console.</a:t>
-            </a:r>
-          </a:p>
-        </p:txBody>
-      </p:sp>
-    </p:spTree>
-  </p:cSld>
-  <p:clrMapOvr>
-    <a:masterClrMapping/>
-  </p:clrMapOvr>
-</p:sld>
-</file>
-
-<file path=ppt/slides/slide9.xml><?xml version="1.0" encoding="utf-8"?>
-<p:sld xmlns:a="http://schemas.openxmlformats.org/drawingml/2006/main" xmlns:p="http://schemas.openxmlformats.org/presentationml/2006/main" xmlns:r="http://schemas.openxmlformats.org/officeDocument/2006/relationships">
-  <p:cSld>
-    <p:spTree>
-      <p:nvGrpSpPr>
-        <p:cNvPr id="1" name=""/>
-        <p:cNvGrpSpPr/>
-        <p:nvPr/>
-      </p:nvGrpSpPr>
-      <p:grpSpPr/>
-      <p:sp>
-        <p:nvSpPr>
-          <p:cNvPr id="2" name="Rectangle 1"/>
-          <p:cNvSpPr/>
-          <p:nvPr/>
-        </p:nvSpPr>
-        <p:spPr>
-          <a:xfrm>
-            <a:off x="0" y="0"/>
-            <a:ext cx="12191695" cy="1005840"/>
-          </a:xfrm>
-          <a:prstGeom prst="rect">
-            <a:avLst/>
-          </a:prstGeom>
-          <a:solidFill>
-            <a:srgbClr val="0B1020"/>
-          </a:solidFill>
-          <a:ln>
-            <a:noFill/>
-          </a:ln>
-        </p:spPr>
-        <p:style>
-          <a:lnRef idx="1">
-            <a:schemeClr val="accent1"/>
-          </a:lnRef>
-          <a:fillRef idx="3">
-            <a:schemeClr val="accent1"/>
-          </a:fillRef>
-          <a:effectRef idx="2">
-            <a:schemeClr val="accent1"/>
-          </a:effectRef>
-          <a:fontRef idx="minor">
-            <a:schemeClr val="lt1"/>
-          </a:fontRef>
-        </p:style>
-        <p:txBody>
-          <a:bodyPr rtlCol="0" anchor="ctr"/>
-          <a:lstStyle/>
-          <a:p>
-            <a:pPr algn="ctr"/>
-          </a:p>
-        </p:txBody>
-      </p:sp>
-      <p:sp>
-        <p:nvSpPr>
-          <p:cNvPr id="3" name="Oval 2"/>
-          <p:cNvSpPr/>
-          <p:nvPr/>
-        </p:nvSpPr>
-        <p:spPr>
-          <a:xfrm>
-            <a:off x="365760" y="320040"/>
-            <a:ext cx="228600" cy="228600"/>
-          </a:xfrm>
-          <a:prstGeom prst="ellipse">
-            <a:avLst/>
-          </a:prstGeom>
-          <a:solidFill>
-            <a:srgbClr val="2C6FB5"/>
-          </a:solidFill>
-          <a:ln>
-            <a:noFill/>
-          </a:ln>
-        </p:spPr>
-        <p:style>
-          <a:lnRef idx="1">
-            <a:schemeClr val="accent1"/>
-          </a:lnRef>
-          <a:fillRef idx="3">
-            <a:schemeClr val="accent1"/>
-          </a:fillRef>
-          <a:effectRef idx="2">
-            <a:schemeClr val="accent1"/>
-          </a:effectRef>
-          <a:fontRef idx="minor">
-            <a:schemeClr val="lt1"/>
-          </a:fontRef>
-        </p:style>
-        <p:txBody>
-          <a:bodyPr rtlCol="0" anchor="ctr"/>
-          <a:lstStyle/>
-          <a:p>
-            <a:pPr algn="ctr"/>
-          </a:p>
-        </p:txBody>
-      </p:sp>
-      <p:sp>
-        <p:nvSpPr>
-          <p:cNvPr id="4" name="TextBox 3"/>
-          <p:cNvSpPr txBox="1"/>
-          <p:nvPr/>
-        </p:nvSpPr>
-        <p:spPr>
-          <a:xfrm>
-            <a:off x="731520" y="201168"/>
-            <a:ext cx="11094415" cy="731520"/>
-          </a:xfrm>
-          <a:prstGeom prst="rect">
-            <a:avLst/>
-          </a:prstGeom>
-          <a:noFill/>
-        </p:spPr>
-        <p:txBody>
-          <a:bodyPr wrap="none" tIns="0" bIns="0">
-            <a:spAutoFit/>
-          </a:bodyPr>
-          <a:lstStyle/>
-          <a:p>
-            <a:r>
-              <a:rPr sz="3000" b="1">
-                <a:solidFill>
-                  <a:srgbClr val="FFFFFF"/>
-                </a:solidFill>
-              </a:rPr>
-              <a:t>Honest limitations</a:t>
-            </a:r>
-          </a:p>
-        </p:txBody>
-      </p:sp>
-      <p:sp>
-        <p:nvSpPr>
-          <p:cNvPr id="5" name="TextBox 4"/>
-          <p:cNvSpPr txBox="1"/>
-          <p:nvPr/>
-        </p:nvSpPr>
-        <p:spPr>
-          <a:xfrm>
-            <a:off x="548640" y="1325880"/>
-            <a:ext cx="11094415" cy="5303520"/>
-          </a:xfrm>
-          <a:prstGeom prst="rect">
-            <a:avLst/>
-          </a:prstGeom>
-          <a:noFill/>
-        </p:spPr>
-        <p:txBody>
-          <a:bodyPr wrap="square" tIns="0" lIns="0" rIns="0"/>
-          <a:lstStyle/>
-          <a:p>
-            <a:pPr>
-              <a:spcBef>
-                <a:spcPts val="0"/>
-              </a:spcBef>
-              <a:spcAft>
-                <a:spcPts val="800"/>
-              </a:spcAft>
-            </a:pPr>
-            <a:r>
-              <a:rPr sz="1400">
-                <a:solidFill>
-                  <a:srgbClr val="141E36"/>
-                </a:solidFill>
-              </a:rPr>
-              <a:t>•  Expectimax, not CFR: a heuristic solver under coarse priors; optimality fails if real factories fall outside the 4 archetypes.</a:t>
-            </a:r>
-          </a:p>
-          <a:p>
-            <a:pPr>
-              <a:spcBef>
-                <a:spcPts val="0"/>
-              </a:spcBef>
-              <a:spcAft>
-                <a:spcPts val="800"/>
-              </a:spcAft>
-            </a:pPr>
-            <a:r>
-              <a:rPr sz="1400">
-                <a:solidFill>
-                  <a:srgbClr val="141E36"/>
-                </a:solidFill>
-              </a:rPr>
-              <a:t>•  The simulator's violation claim (12–44% historically; 20–40% in the current artefact) was disproven by our own experiment (0/94, upper bound 3.1%).</a:t>
-            </a:r>
-          </a:p>
-          <a:p>
-            <a:pPr>
-              <a:spcBef>
-                <a:spcPts val="0"/>
-              </a:spcBef>
-              <a:spcAft>
-                <a:spcPts val="800"/>
-              </a:spcAft>
-            </a:pPr>
-            <a:r>
-              <a:rPr sz="1400">
-                <a:solidFill>
-                  <a:srgbClr val="141E36"/>
-                </a:solidFill>
-              </a:rPr>
-              <a:t>•  Prior miss is asymmetric: overestimating a supplier's reserve costs real margin (−0.102); underestimating is nearly free.</a:t>
-            </a:r>
-          </a:p>
-          <a:p>
-            <a:pPr>
-              <a:spcBef>
-                <a:spcPts val="0"/>
-              </a:spcBef>
-              <a:spcAft>
-                <a:spcPts val="800"/>
-              </a:spcAft>
-            </a:pPr>
-            <a:r>
-              <a:rPr sz="1400">
-                <a:solidFill>
-                  <a:srgbClr val="141E36"/>
-                </a:solidFill>
-              </a:rPr>
-              <a:t>•  Supplier quotes in demos are synthetic (adversary models), not real factory quotes. See LIMITATIONS §零 data classification.</a:t>
-            </a:r>
-          </a:p>
-          <a:p>
-            <a:pPr>
-              <a:spcBef>
-                <a:spcPts val="0"/>
-              </a:spcBef>
-              <a:spcAft>
-                <a:spcPts val="800"/>
-              </a:spcAft>
-            </a:pPr>
-            <a:r>
-              <a:rPr sz="1400">
-                <a:solidFill>
-                  <a:srgbClr val="141E36"/>
-                </a:solidFill>
-              </a:rPr>
-              <a:t>•  Calibration constants are chosen, not fitted; no real negotiation logs exist yet.</a:t>
+              <a:t>Working deadline used for this pack: 11:00 London (BST), 18 October 2026. Confirm the form.</a:t>
             </a:r>
           </a:p>
         </p:txBody>

</xml_diff>

<commit_message>
feat: put Gemma and AMD live mode on the demo path
Default new Stage-2 calls to Gemma-4-31B-IT, keep Qwen as the logged alternative, and record one chat on the AMD probe when a key is present. The dashboard can paste a quote or a labeled simulation and show an AMD reading without letting the model set the price.

Co-authored-by: Hao En Fu <Fu93@users.noreply.github.com>
</commit_message>
<xml_diff>
--- a/results/pitch.pptx
+++ b/results/pitch.pptx
@@ -13,6 +13,7 @@
     <p:sldId id="261" r:id="rId12"/>
     <p:sldId id="262" r:id="rId13"/>
     <p:sldId id="263" r:id="rId14"/>
+    <p:sldId id="264" r:id="rId15"/>
   </p:sldIdLst>
   <p:sldSz cx="12192000" cy="6858000" type="screen4x3"/>
   <p:notesSz cx="6858000" cy="9144000"/>
@@ -3219,6 +3220,21 @@
                   <a:srgbClr val="1C1712"/>
                 </a:solidFill>
               </a:rPr>
+              <a:t>Small cross-border sellers lose margin negotiating factory quotes alone, or pay an agent to do it.</a:t>
+            </a:r>
+          </a:p>
+          <a:p>
+            <a:pPr>
+              <a:spcAft>
+                <a:spcPts val="1000"/>
+              </a:spcAft>
+            </a:pPr>
+            <a:r>
+              <a:rPr sz="1600">
+                <a:solidFill>
+                  <a:srgbClr val="1C1712"/>
+                </a:solidFill>
+              </a:rPr>
               <a:t>One operator. The engine sets the price. A human sends the offer.</a:t>
             </a:r>
           </a:p>
@@ -3505,7 +3521,7 @@
                   <a:srgbClr val="FBF7F0"/>
                 </a:solidFill>
               </a:rPr>
-              <a:t>3. Split</a:t>
+              <a:t>3. Market, revenue, competition</a:t>
             </a:r>
           </a:p>
         </p:txBody>
@@ -3543,7 +3559,7 @@
                   <a:srgbClr val="1C1712"/>
                 </a:solidFill>
               </a:rPr>
-              <a:t>Solver decides. The decision core does not ask a language model what to pay.</a:t>
+              <a:t>Target user: a small cross-border seller who sources from factories and negotiates in chat.</a:t>
             </a:r>
           </a:p>
           <a:p>
@@ -3558,7 +3574,7 @@
                   <a:srgbClr val="1C1712"/>
                 </a:solidFill>
               </a:rPr>
-              <a:t>Model phrases. An optional call can classify a message or draft wording.</a:t>
+              <a:t>Revenue model, proposed and not earned: a desk subscription, or a share of savings versus the first-round best quote. No revenue is claimed.</a:t>
             </a:r>
           </a:p>
           <a:p>
@@ -3573,7 +3589,7 @@
                   <a:srgbClr val="1C1712"/>
                 </a:solidFill>
               </a:rPr>
-              <a:t>Human sends. The Chrome extension (Manifest V3) shows a card. It cannot press Send.</a:t>
+              <a:t>Competitors: LLM negotiation agents that let the model set the price; sourcing agents who take a commission; marketplace tools built into Alibaba-style sites.</a:t>
             </a:r>
           </a:p>
           <a:p>
@@ -3588,7 +3604,22 @@
                   <a:srgbClr val="1C1712"/>
                 </a:solidFill>
               </a:rPr>
-              <a:t>Code: src/engine/solver.py, src/engine/multi_solver.py, extension/.</a:t>
+              <a:t>Roadmap: a public offline demo, AMD live reads only when a key is set, measured extraction accuracy only after a logged run, and the human keeps the send button.</a:t>
+            </a:r>
+          </a:p>
+          <a:p>
+            <a:pPr>
+              <a:spcAft>
+                <a:spcPts val="1000"/>
+              </a:spcAft>
+            </a:pPr>
+            <a:r>
+              <a:rPr sz="1600">
+                <a:solidFill>
+                  <a:srgbClr val="1C1712"/>
+                </a:solidFill>
+              </a:rPr>
+              <a:t>No market-size number is stated. None was sourced for this pack.</a:t>
             </a:r>
           </a:p>
         </p:txBody>
@@ -3682,7 +3713,7 @@
                   <a:srgbClr val="FBF7F0"/>
                 </a:solidFill>
               </a:rPr>
-              <a:t>4. Decision core</a:t>
+              <a:t>4. Split</a:t>
             </a:r>
           </a:p>
         </p:txBody>
@@ -3720,7 +3751,7 @@
                   <a:srgbClr val="1C1712"/>
                 </a:solidFill>
               </a:rPr>
-              <a:t>A belief about the supplier reserve, then a vectorised Expectimax search over openings and concession curves.</a:t>
+              <a:t>Hybrid desk. The criteria this workflow is written for are Hybrid, Becreatives, and Vibe Generation.</a:t>
             </a:r>
           </a:p>
           <a:p>
@@ -3735,7 +3766,7 @@
                   <a:srgbClr val="1C1712"/>
                 </a:solidFill>
               </a:rPr>
-              <a:t>Read the recommended price and the breakdown probability off the dashboard you just captured.</a:t>
+              <a:t>Solver decides. The decision core does not ask a language model what to pay.</a:t>
             </a:r>
           </a:p>
           <a:p>
@@ -3750,7 +3781,37 @@
                   <a:srgbClr val="1C1712"/>
                 </a:solidFill>
               </a:rPr>
-              <a:t>This slide does not state a latency. Use the number on the screen.</a:t>
+              <a:t>Model phrases. An optional call can classify a message or draft wording.</a:t>
+            </a:r>
+          </a:p>
+          <a:p>
+            <a:pPr>
+              <a:spcAft>
+                <a:spcPts val="1000"/>
+              </a:spcAft>
+            </a:pPr>
+            <a:r>
+              <a:rPr sz="1600">
+                <a:solidFill>
+                  <a:srgbClr val="1C1712"/>
+                </a:solidFill>
+              </a:rPr>
+              <a:t>Human sends. The Chrome extension (Manifest V3) shows a card. It cannot press Send.</a:t>
+            </a:r>
+          </a:p>
+          <a:p>
+            <a:pPr>
+              <a:spcAft>
+                <a:spcPts val="1000"/>
+              </a:spcAft>
+            </a:pPr>
+            <a:r>
+              <a:rPr sz="1600">
+                <a:solidFill>
+                  <a:srgbClr val="1C1712"/>
+                </a:solidFill>
+              </a:rPr>
+              <a:t>Code: src/engine/solver.py, src/engine/multi_solver.py, extension/.</a:t>
             </a:r>
           </a:p>
         </p:txBody>
@@ -3844,7 +3905,7 @@
                   <a:srgbClr val="FBF7F0"/>
                 </a:solidFill>
               </a:rPr>
-              <a:t>5. AMD language layer</a:t>
+              <a:t>5. Decision core</a:t>
             </a:r>
           </a:p>
         </p:txBody>
@@ -3882,7 +3943,7 @@
                   <a:srgbClr val="1C1712"/>
                 </a:solidFill>
               </a:rPr>
-              <a:t>Sample endpoint: https://developer.amd.com.cn/radeon/api/v1.</a:t>
+              <a:t>A belief about the supplier reserve, then a vectorised Expectimax search over openings and concession curves.</a:t>
             </a:r>
           </a:p>
           <a:p>
@@ -3897,7 +3958,7 @@
                   <a:srgbClr val="1C1712"/>
                 </a:solidFill>
               </a:rPr>
-              <a:t>Committed log results/real_llm_benchmark_100.json (2026-10-15): model Qwen3.8-Flash-Next, 348 calls, average latency 16.81 s, cost $0.108444.</a:t>
+              <a:t>Read the recommended price and the breakdown probability off the dashboard you just captured.</a:t>
             </a:r>
           </a:p>
           <a:p>
@@ -3912,7 +3973,7 @@
                   <a:srgbClr val="1C1712"/>
                 </a:solidFill>
               </a:rPr>
-              <a:t>That file does not store an HTTP status. status: ok from scripts/verify_amd_endpoint.py means that process received HTTP 200. skipped_no_credentials is not a successful check.</a:t>
+              <a:t>This slide does not state a latency. Use the number on the screen.</a:t>
             </a:r>
           </a:p>
         </p:txBody>
@@ -4006,7 +4067,7 @@
                   <a:srgbClr val="FBF7F0"/>
                 </a:solidFill>
               </a:rPr>
-              <a:t>6. AMD compute layer</a:t>
+              <a:t>6. AMD language layer</a:t>
             </a:r>
           </a:p>
         </p:txBody>
@@ -4044,7 +4105,7 @@
                   <a:srgbClr val="1C1712"/>
                 </a:solidFill>
               </a:rPr>
-              <a:t>TRADEFLOW_SOLVER_BACKEND selects NumPy (default) or a CuPy/ROCm request.</a:t>
+              <a:t>Sample endpoint: https://developer.amd.com.cn/radeon/api/v1.</a:t>
             </a:r>
           </a:p>
           <a:p>
@@ -4059,7 +4120,7 @@
                   <a:srgbClr val="1C1712"/>
                 </a:solidFill>
               </a:rPr>
-              <a:t>results/bench.json is a CPU measurement (is_gpu_active: false).</a:t>
+              <a:t>Committed log results/real_llm_benchmark_100.json (2026-10-15): model Qwen3.8-Flash-Next, 348 calls, average latency 16.81 s, cost $0.108444.</a:t>
             </a:r>
           </a:p>
           <a:p>
@@ -4074,7 +4135,7 @@
                   <a:srgbClr val="1C1712"/>
                 </a:solidFill>
               </a:rPr>
-              <a:t>The MI300X column is a theoretical roofline lower-bound estimate, not measured.</a:t>
+              <a:t>That file does not store an HTTP status. status: ok from scripts/verify_amd_endpoint.py means that process received HTTP 200. skipped_no_credentials is not a successful check.</a:t>
             </a:r>
           </a:p>
           <a:p>
@@ -4089,22 +4150,7 @@
                   <a:srgbClr val="1C1712"/>
                 </a:solidFill>
               </a:rPr>
-              <a:t>Formula: lower_bound_seconds = (working_set_mb * 1024 * 1024) / (5.3e12).</a:t>
-            </a:r>
-          </a:p>
-          <a:p>
-            <a:pPr>
-              <a:spcAft>
-                <a:spcPts val="1000"/>
-              </a:spcAft>
-            </a:pPr>
-            <a:r>
-              <a:rPr sz="1600">
-                <a:solidFill>
-                  <a:srgbClr val="1C1712"/>
-                </a:solidFill>
-              </a:rPr>
-              <a:t>No AMD GPU measurement is in the repo unless a sibling benchmark JSON says ran_on_amd_gpu: true. Do not narrate a speedup.</a:t>
+              <a:t>The default model for a new Stage-2 call is Gemma-4-31B-IT. The committed log above is Qwen3.8-Flash-Next, not Gemma. No committed Gemma latency.</a:t>
             </a:r>
           </a:p>
         </p:txBody>
@@ -4198,7 +4244,7 @@
                   <a:srgbClr val="FBF7F0"/>
                 </a:solidFill>
               </a:rPr>
-              <a:t>7. Evidence, with the baseline named</a:t>
+              <a:t>7. AMD compute layer</a:t>
             </a:r>
           </a:p>
         </p:txBody>
@@ -4236,7 +4282,7 @@
                   <a:srgbClr val="1C1712"/>
                 </a:solidFill>
               </a:rPr>
-              <a:t>Self-play (results/self_play_benchmark.md): engine savings versus that table's walk-away ceiling run from 8.8% to 20.0%. Hard-Bargainer 8.8% versus the fixed baseline 9.2%. 20 matches, 5 archetypes, seed 42. Not the auction headline.</a:t>
+              <a:t>TRADEFLOW_SOLVER_BACKEND selects NumPy (default) or a CuPy/ROCm request.</a:t>
             </a:r>
           </a:p>
           <a:p>
@@ -4251,7 +4297,7 @@
                   <a:srgbClr val="1C1712"/>
                 </a:solidFill>
               </a:rPr>
-              <a:t>Real-model log, different experiment: Bluffing Hardliner deal rate 61.11%. 0 budget violations in 94 completed matches.</a:t>
+              <a:t>results/bench.json is a CPU measurement (is_gpu_active: false).</a:t>
             </a:r>
           </a:p>
           <a:p>
@@ -4266,7 +4312,7 @@
                   <a:srgbClr val="1C1712"/>
                 </a:solidFill>
               </a:rPr>
-              <a:t>Held-out intent accuracy on the synthetic set: 63.08% (195 of 500 held out).</a:t>
+              <a:t>The MI300X column is a theoretical roofline lower-bound estimate, not measured.</a:t>
             </a:r>
           </a:p>
           <a:p>
@@ -4281,7 +4327,7 @@
                   <a:srgbClr val="1C1712"/>
                 </a:solidFill>
               </a:rPr>
-              <a:t>Auction headline is savings versus the first-round best quote. Versus target is shown, including when that figure is negative. The walk-away ceiling figure is secondary.</a:t>
+              <a:t>Formula: lower_bound_seconds = (working_set_mb * 1024 * 1024) / (5.3e12).</a:t>
             </a:r>
           </a:p>
           <a:p>
@@ -4296,37 +4342,7 @@
                   <a:srgbClr val="1C1712"/>
                 </a:solidFill>
               </a:rPr>
-              <a:t>Headline savings vs first-round best quote: 5.0% (¥6,600.00 total)</a:t>
-            </a:r>
-          </a:p>
-          <a:p>
-            <a:pPr>
-              <a:spcAft>
-                <a:spcPts val="1000"/>
-              </a:spcAft>
-            </a:pPr>
-            <a:r>
-              <a:rPr sz="1600">
-                <a:solidFill>
-                  <a:srgbClr val="1C1712"/>
-                </a:solidFill>
-              </a:rPr>
-              <a:t>Versus target: -5.0% (¥-6,000.00 total). A negative figure means the settled price is above target.</a:t>
-            </a:r>
-          </a:p>
-          <a:p>
-            <a:pPr>
-              <a:spcAft>
-                <a:spcPts val="1000"/>
-              </a:spcAft>
-            </a:pPr>
-            <a:r>
-              <a:rPr sz="1600">
-                <a:solidFill>
-                  <a:srgbClr val="1C1712"/>
-                </a:solidFill>
-              </a:rPr>
-              <a:t>Secondary, versus walk-away ceiling: 22.2% (¥36,000.00 total)</a:t>
+              <a:t>No AMD GPU measurement is in the repo unless a sibling benchmark JSON says ran_on_amd_gpu: true. Do not narrate a speedup.</a:t>
             </a:r>
           </a:p>
         </p:txBody>
@@ -4420,7 +4436,7 @@
                   <a:srgbClr val="FBF7F0"/>
                 </a:solidFill>
               </a:rPr>
-              <a:t>8. Limits and how to run</a:t>
+              <a:t>8. Evidence, with the baseline named</a:t>
             </a:r>
           </a:p>
         </p:txBody>
@@ -4458,7 +4474,7 @@
                   <a:srgbClr val="1C1712"/>
                 </a:solidFill>
               </a:rPr>
-              <a:t>cp .env.example .env &amp;&amp; docker compose up --build, then open http://localhost:8000.</a:t>
+              <a:t>Self-play (results/self_play_benchmark.md): engine savings versus that table's walk-away ceiling run from 8.8% to 20.0%. Hard-Bargainer 8.8% versus the fixed baseline 9.2%. 20 matches, 5 archetypes, seed 42. Not the auction headline.</a:t>
             </a:r>
           </a:p>
           <a:p>
@@ -4473,7 +4489,7 @@
                   <a:srgbClr val="1C1712"/>
                 </a:solidFill>
               </a:rPr>
-              <a:t>Placeholder keys are ignored. /health reports offline_demo and the solver backend.</a:t>
+              <a:t>Real-model log, different experiment: Bluffing Hardliner deal rate 61.11%. 0 budget violations in 94 completed matches.</a:t>
             </a:r>
           </a:p>
           <a:p>
@@ -4488,7 +4504,259 @@
                   <a:srgbClr val="1C1712"/>
                 </a:solidFill>
               </a:rPr>
-              <a:t>No factory deal. No shipped MI300X timing. MIT. Public repo.</a:t>
+              <a:t>Held-out intent accuracy on the synthetic set: 63.08% (195 of 500 held out).</a:t>
+            </a:r>
+          </a:p>
+          <a:p>
+            <a:pPr>
+              <a:spcAft>
+                <a:spcPts val="1000"/>
+              </a:spcAft>
+            </a:pPr>
+            <a:r>
+              <a:rPr sz="1600">
+                <a:solidFill>
+                  <a:srgbClr val="1C1712"/>
+                </a:solidFill>
+              </a:rPr>
+              <a:t>Auction headline is savings versus the first-round best quote. Versus target is shown, including when that figure is negative. The walk-away ceiling figure is secondary.</a:t>
+            </a:r>
+          </a:p>
+          <a:p>
+            <a:pPr>
+              <a:spcAft>
+                <a:spcPts val="1000"/>
+              </a:spcAft>
+            </a:pPr>
+            <a:r>
+              <a:rPr sz="1600">
+                <a:solidFill>
+                  <a:srgbClr val="1C1712"/>
+                </a:solidFill>
+              </a:rPr>
+              <a:t>Headline savings vs first-round best quote: 5.0% (¥6,600.00 total)</a:t>
+            </a:r>
+          </a:p>
+          <a:p>
+            <a:pPr>
+              <a:spcAft>
+                <a:spcPts val="1000"/>
+              </a:spcAft>
+            </a:pPr>
+            <a:r>
+              <a:rPr sz="1600">
+                <a:solidFill>
+                  <a:srgbClr val="1C1712"/>
+                </a:solidFill>
+              </a:rPr>
+              <a:t>Versus target: -5.0% (¥-6,000.00 total). A negative figure means the settled price is above target.</a:t>
+            </a:r>
+          </a:p>
+          <a:p>
+            <a:pPr>
+              <a:spcAft>
+                <a:spcPts val="1000"/>
+              </a:spcAft>
+            </a:pPr>
+            <a:r>
+              <a:rPr sz="1600">
+                <a:solidFill>
+                  <a:srgbClr val="1C1712"/>
+                </a:solidFill>
+              </a:rPr>
+              <a:t>Secondary, versus walk-away ceiling: 22.2% (¥36,000.00 total)</a:t>
+            </a:r>
+          </a:p>
+          <a:p>
+            <a:pPr>
+              <a:spcAft>
+                <a:spcPts val="1000"/>
+              </a:spcAft>
+            </a:pPr>
+            <a:r>
+              <a:rPr sz="1600">
+                <a:solidFill>
+                  <a:srgbClr val="1C1712"/>
+                </a:solidFill>
+              </a:rPr>
+              <a:t>Offline comparison results/llm_vs_tradeflow.json: 24 episodes, seed 42, buyer offline_accept_opening. Not an AMD call. TradeFlow budget violations 0.00%, deal rate 50.00%, average savings versus the supplier opening 22.24%. Stand-in budget violations 100.00%, deal rate 100.00%, average savings 0.00%. Simulation. Not the auction headline.</a:t>
+            </a:r>
+          </a:p>
+        </p:txBody>
+      </p:sp>
+    </p:spTree>
+  </p:cSld>
+  <p:clrMapOvr>
+    <a:masterClrMapping/>
+  </p:clrMapOvr>
+</p:sld>
+</file>
+
+<file path=ppt/slides/slide9.xml><?xml version="1.0" encoding="utf-8"?>
+<p:sld xmlns:a="http://schemas.openxmlformats.org/drawingml/2006/main" xmlns:p="http://schemas.openxmlformats.org/presentationml/2006/main" xmlns:r="http://schemas.openxmlformats.org/officeDocument/2006/relationships">
+  <p:cSld>
+    <p:spTree>
+      <p:nvGrpSpPr>
+        <p:cNvPr id="1" name=""/>
+        <p:cNvGrpSpPr/>
+        <p:nvPr/>
+      </p:nvGrpSpPr>
+      <p:grpSpPr/>
+      <p:sp>
+        <p:nvSpPr>
+          <p:cNvPr id="2" name="Rectangle 1"/>
+          <p:cNvSpPr/>
+          <p:nvPr/>
+        </p:nvSpPr>
+        <p:spPr>
+          <a:xfrm>
+            <a:off x="0" y="0"/>
+            <a:ext cx="12192000" cy="960120"/>
+          </a:xfrm>
+          <a:prstGeom prst="rect">
+            <a:avLst/>
+          </a:prstGeom>
+          <a:solidFill>
+            <a:srgbClr val="1E3A4C"/>
+          </a:solidFill>
+          <a:ln>
+            <a:noFill/>
+          </a:ln>
+        </p:spPr>
+        <p:style>
+          <a:lnRef idx="1">
+            <a:schemeClr val="accent1"/>
+          </a:lnRef>
+          <a:fillRef idx="3">
+            <a:schemeClr val="accent1"/>
+          </a:fillRef>
+          <a:effectRef idx="2">
+            <a:schemeClr val="accent1"/>
+          </a:effectRef>
+          <a:fontRef idx="minor">
+            <a:schemeClr val="lt1"/>
+          </a:fontRef>
+        </p:style>
+        <p:txBody>
+          <a:bodyPr rtlCol="0" anchor="ctr"/>
+          <a:lstStyle/>
+          <a:p>
+            <a:pPr algn="ctr"/>
+          </a:p>
+        </p:txBody>
+      </p:sp>
+      <p:sp>
+        <p:nvSpPr>
+          <p:cNvPr id="3" name="TextBox 2"/>
+          <p:cNvSpPr txBox="1"/>
+          <p:nvPr/>
+        </p:nvSpPr>
+        <p:spPr>
+          <a:xfrm>
+            <a:off x="411480" y="201168"/>
+            <a:ext cx="11369040" cy="640080"/>
+          </a:xfrm>
+          <a:prstGeom prst="rect">
+            <a:avLst/>
+          </a:prstGeom>
+          <a:noFill/>
+        </p:spPr>
+        <p:txBody>
+          <a:bodyPr wrap="none">
+            <a:spAutoFit/>
+          </a:bodyPr>
+          <a:lstStyle/>
+          <a:p>
+            <a:r>
+              <a:rPr sz="2800" b="1">
+                <a:solidFill>
+                  <a:srgbClr val="FBF7F0"/>
+                </a:solidFill>
+              </a:rPr>
+              <a:t>9. Limits and roadmap</a:t>
+            </a:r>
+          </a:p>
+        </p:txBody>
+      </p:sp>
+      <p:sp>
+        <p:nvSpPr>
+          <p:cNvPr id="4" name="TextBox 3"/>
+          <p:cNvSpPr txBox="1"/>
+          <p:nvPr/>
+        </p:nvSpPr>
+        <p:spPr>
+          <a:xfrm>
+            <a:off x="457200" y="1234440"/>
+            <a:ext cx="11277600" cy="5394960"/>
+          </a:xfrm>
+          <a:prstGeom prst="rect">
+            <a:avLst/>
+          </a:prstGeom>
+          <a:noFill/>
+        </p:spPr>
+        <p:txBody>
+          <a:bodyPr wrap="square">
+            <a:spAutoFit/>
+          </a:bodyPr>
+          <a:lstStyle/>
+          <a:p>
+            <a:pPr>
+              <a:spcAft>
+                <a:spcPts val="1000"/>
+              </a:spcAft>
+            </a:pPr>
+            <a:r>
+              <a:rPr sz="1600">
+                <a:solidFill>
+                  <a:srgbClr val="1C1712"/>
+                </a:solidFill>
+              </a:rPr>
+              <a:t>cp .env.example .env &amp;&amp; docker compose up --build, then open http://localhost:8000. render.yaml is the public-demo blueprint. No hostname is claimed until a deploy exists.</a:t>
+            </a:r>
+          </a:p>
+          <a:p>
+            <a:pPr>
+              <a:spcAft>
+                <a:spcPts val="1000"/>
+              </a:spcAft>
+            </a:pPr>
+            <a:r>
+              <a:rPr sz="1600">
+                <a:solidFill>
+                  <a:srgbClr val="1C1712"/>
+                </a:solidFill>
+              </a:rPr>
+              <a:t>Placeholder keys are ignored. /health reports offline_demo and the solver backend. AMD live mode stays off unless a real VLLM_API_KEY is set and the operator turns it on.</a:t>
+            </a:r>
+          </a:p>
+          <a:p>
+            <a:pPr>
+              <a:spcAft>
+                <a:spcPts val="1000"/>
+              </a:spcAft>
+            </a:pPr>
+            <a:r>
+              <a:rPr sz="1600">
+                <a:solidFill>
+                  <a:srgbClr val="1C1712"/>
+                </a:solidFill>
+              </a:rPr>
+              <a:t>No factory deal. No shipped MI300X timing. No committed Gemma latency. MIT. Public repo.</a:t>
+            </a:r>
+          </a:p>
+          <a:p>
+            <a:pPr>
+              <a:spcAft>
+                <a:spcPts val="1000"/>
+              </a:spcAft>
+            </a:pPr>
+            <a:r>
+              <a:rPr sz="1600">
+                <a:solidFill>
+                  <a:srgbClr val="1C1712"/>
+                </a:solidFill>
+              </a:rPr>
+              <a:t>Roadmap: keep the human on the send button, log a real Gemma chat only when a key is present, and publish extraction accuracy only after that log exists.</a:t>
             </a:r>
           </a:p>
           <a:p>

</xml_diff>

<commit_message>
feat: attach Comtrade customs context without letting it set the price
Sessions, the auction summary, and the extension Evidence tab carry a
UK-from-China market_context block, or an explicit unavailable state.
The solver, the recommended price, and the circuit breaker do not read it.
HS 6601 figures in the market note come from a live preview snapshot.

Co-authored-by: Hao En Fu <Fu93@users.noreply.github.com>
</commit_message>
<xml_diff>
--- a/results/pitch.pptx
+++ b/results/pitch.pptx
@@ -3559,7 +3559,7 @@
                   <a:srgbClr val="1C1712"/>
                 </a:solidFill>
               </a:rPr>
-              <a:t>Target user: a small cross-border seller who sources from factories and negotiates in chat.</a:t>
+              <a:t>Target user is a hypothesis: a small cross-border seller who sources from factories and negotiates in chat.</a:t>
             </a:r>
           </a:p>
           <a:p>
@@ -3574,7 +3574,7 @@
                   <a:srgbClr val="1C1712"/>
                 </a:solidFill>
               </a:rPr>
-              <a:t>Revenue model, proposed and not earned: a desk subscription, or a share of savings versus the first-round best quote. No revenue is claimed.</a:t>
+              <a:t>HMRC 2025: 334,294 UK goods importers. SAM proxy 132,484 to 239,616 (formula in docs/MARKET_ANALYSIS.md).</a:t>
             </a:r>
           </a:p>
           <a:p>
@@ -3589,7 +3589,7 @@
                   <a:srgbClr val="1C1712"/>
                 </a:solidFill>
               </a:rPr>
-              <a:t>Competitors: LLM negotiation agents that let the model set the price; sourcing agents who take a commission; marketplace tools built into Alibaba-style sites.</a:t>
+              <a:t>UK goods from China, 2025: GBP 69.7 billion (ONS/DBT). Includes precious metals and large corporates.</a:t>
             </a:r>
           </a:p>
           <a:p>
@@ -3604,7 +3604,7 @@
                   <a:srgbClr val="1C1712"/>
                 </a:solidFill>
               </a:rPr>
-              <a:t>Roadmap: a public offline demo, AMD live reads only when a key is set, measured extraction accuracy only after a logged run, and the human keeps the send button.</a:t>
+              <a:t>Savings-pool ceiling GBP 1.05 billion to GBP 2.09 billion. Large-buyer 1.5 to 3 percent band. Not a TradeFlow result.</a:t>
             </a:r>
           </a:p>
           <a:p>
@@ -3619,7 +3619,37 @@
                   <a:srgbClr val="1C1712"/>
                 </a:solidFill>
               </a:rPr>
-              <a:t>No market-size number is stated. None was sourced for this pack.</a:t>
+              <a:t>Umbrellas (HS 6601) are the demo wedge. Other codes use the Comtrade preview script. Customs unit value is reference only and does not set the price.</a:t>
+            </a:r>
+          </a:p>
+          <a:p>
+            <a:pPr>
+              <a:spcAft>
+                <a:spcPts val="1000"/>
+              </a:spcAft>
+            </a:pPr>
+            <a:r>
+              <a:rPr sz="1600">
+                <a:solidFill>
+                  <a:srgbClr val="1C1712"/>
+                </a:solidFill>
+              </a:rPr>
+              <a:t>Revenue model, proposed and not earned: a desk subscription, or a share of savings versus the first-round best quote. No revenue is claimed.</a:t>
+            </a:r>
+          </a:p>
+          <a:p>
+            <a:pPr>
+              <a:spcAft>
+                <a:spcPts val="1000"/>
+              </a:spcAft>
+            </a:pPr>
+            <a:r>
+              <a:rPr sz="1600">
+                <a:solidFill>
+                  <a:srgbClr val="1C1712"/>
+                </a:solidFill>
+              </a:rPr>
+              <a:t>Public prices: Accio, and Alibaba RFQ free for buyers. Pactum, Keelvar, Fairmarkit, Jaggaer, Zycus, Globality are quote-based.</a:t>
             </a:r>
           </a:p>
         </p:txBody>

</xml_diff>